<commit_message>
Notes d'orateur d'Imane (diapos 1-7 et 14)
</commit_message>
<xml_diff>
--- a/soutenance/presentation_fusion.pptx
+++ b/soutenance/presentation_fusion.pptx
@@ -125,6 +125,14 @@
 </p:presentation>
 </file>
 
+<file path=ppt/revisionInfo.xml><?xml version="1.0" encoding="utf-8"?>
+<p1510:revInfo xmlns:a="http://schemas.openxmlformats.org/drawingml/2006/main" xmlns:r="http://schemas.openxmlformats.org/officeDocument/2006/relationships" xmlns:p1510="http://schemas.microsoft.com/office/powerpoint/2015/10/main">
+  <p1510:revLst>
+    <p1510:client id="{0A670903-C729-E12F-D5F2-EE588F6DDDE2}" v="1" dt="2026-10-15T16:20:48.401"/>
+  </p1510:revLst>
+</p1510:revInfo>
+</file>
+
 <file path=ppt/notesMasters/notesMaster1.xml><?xml version="1.0" encoding="utf-8"?>
 <p:notesMaster xmlns:a="http://schemas.openxmlformats.org/drawingml/2006/main" xmlns:r="http://schemas.openxmlformats.org/officeDocument/2006/relationships" xmlns:p="http://schemas.openxmlformats.org/presentationml/2006/main">
   <p:cSld>
@@ -206,7 +214,7 @@
           </a:lstStyle>
           <a:p>
             <a:fld id="{4FD55F9A-7859-46FE-8A5C-4C101A73E515}" type="datetimeFigureOut">
-              <a:t>11/10/2026</a:t>
+              <a:t>15/10/2026</a:t>
             </a:fld>
             <a:endParaRPr lang="fr-FR"/>
           </a:p>
@@ -518,8 +526,286 @@
           <a:p>
             <a:r>
               <a:rPr lang="en-US" dirty="0"/>
-              <a:t>Présentation : A (Imane). Objectif en une phrase : pour une ordonnance, détecter les associations à risque, les classer par gravité et expliquer chaque alerte, sans noyer le prescripteur. Préciser : prototype pédagogique, pas un dispositif médical.</a:t>
-            </a:r>
+              <a:t>Bonjour à </a:t>
+            </a:r>
+            <a:r>
+              <a:rPr lang="en-US" dirty="0" err="1"/>
+              <a:t>tous</a:t>
+            </a:r>
+            <a:r>
+              <a:rPr lang="en-US" dirty="0"/>
+              <a:t>. Avec Mohamed Aziz Braham, nous </a:t>
+            </a:r>
+            <a:r>
+              <a:rPr lang="en-US" dirty="0" err="1"/>
+              <a:t>allons</a:t>
+            </a:r>
+            <a:r>
+              <a:rPr lang="en-US" dirty="0"/>
+              <a:t> vous </a:t>
+            </a:r>
+            <a:r>
+              <a:rPr lang="en-US" dirty="0" err="1"/>
+              <a:t>présenter</a:t>
+            </a:r>
+            <a:r>
+              <a:rPr lang="en-US" dirty="0"/>
+              <a:t> </a:t>
+            </a:r>
+            <a:r>
+              <a:rPr lang="en-US" dirty="0" err="1"/>
+              <a:t>notre</a:t>
+            </a:r>
+            <a:r>
+              <a:rPr lang="en-US" dirty="0"/>
+              <a:t> mini-</a:t>
+            </a:r>
+            <a:r>
+              <a:rPr lang="en-US" dirty="0" err="1"/>
+              <a:t>projet</a:t>
+            </a:r>
+            <a:r>
+              <a:rPr lang="en-US" dirty="0"/>
+              <a:t> </a:t>
+            </a:r>
+            <a:r>
+              <a:rPr lang="en-US" dirty="0" err="1"/>
+              <a:t>d’intelligence</a:t>
+            </a:r>
+            <a:r>
+              <a:rPr lang="en-US" dirty="0"/>
+              <a:t> </a:t>
+            </a:r>
+            <a:r>
+              <a:rPr lang="en-US" dirty="0" err="1"/>
+              <a:t>artificielle</a:t>
+            </a:r>
+            <a:r>
+              <a:rPr lang="en-US" dirty="0"/>
+              <a:t> </a:t>
+            </a:r>
+            <a:r>
+              <a:rPr lang="en-US" dirty="0" err="1"/>
+              <a:t>hybride</a:t>
+            </a:r>
+            <a:r>
+              <a:rPr lang="en-US" dirty="0"/>
+              <a:t> : un </a:t>
+            </a:r>
+            <a:r>
+              <a:rPr lang="en-US" dirty="0" err="1"/>
+              <a:t>système</a:t>
+            </a:r>
+            <a:r>
+              <a:rPr lang="en-US" dirty="0"/>
+              <a:t> qui </a:t>
+            </a:r>
+            <a:r>
+              <a:rPr lang="en-US" dirty="0" err="1"/>
+              <a:t>vérifie</a:t>
+            </a:r>
+            <a:r>
+              <a:rPr lang="en-US" dirty="0"/>
+              <a:t> </a:t>
+            </a:r>
+            <a:r>
+              <a:rPr lang="en-US" dirty="0" err="1"/>
+              <a:t>une</a:t>
+            </a:r>
+            <a:r>
+              <a:rPr lang="en-US" dirty="0"/>
+              <a:t> ordonnance à </a:t>
+            </a:r>
+            <a:r>
+              <a:rPr lang="en-US" dirty="0" err="1"/>
+              <a:t>l’aide</a:t>
+            </a:r>
+            <a:r>
+              <a:rPr lang="en-US" dirty="0"/>
+              <a:t> d’un </a:t>
+            </a:r>
+            <a:r>
+              <a:rPr lang="en-US" dirty="0" err="1"/>
+              <a:t>graphe</a:t>
+            </a:r>
+            <a:r>
+              <a:rPr lang="en-US" dirty="0"/>
+              <a:t> de </a:t>
+            </a:r>
+            <a:r>
+              <a:rPr lang="en-US" dirty="0" err="1"/>
+              <a:t>connaissances</a:t>
+            </a:r>
+            <a:r>
+              <a:rPr lang="en-US" dirty="0"/>
+              <a:t> et de </a:t>
+            </a:r>
+            <a:r>
+              <a:rPr lang="en-US" dirty="0" err="1"/>
+              <a:t>règles</a:t>
+            </a:r>
+            <a:r>
+              <a:rPr lang="en-US" dirty="0"/>
+              <a:t> </a:t>
+            </a:r>
+            <a:r>
+              <a:rPr lang="en-US" dirty="0" err="1"/>
+              <a:t>médicales</a:t>
+            </a:r>
+            <a:r>
+              <a:rPr lang="en-US" dirty="0"/>
+              <a:t>.</a:t>
+            </a:r>
+            <a:br>
+              <a:rPr lang="en-US" dirty="0">
+                <a:cs typeface="+mn-lt"/>
+              </a:rPr>
+            </a:br>
+            <a:r>
+              <a:rPr lang="en-US" dirty="0" err="1"/>
+              <a:t>L’objectif</a:t>
+            </a:r>
+            <a:r>
+              <a:rPr lang="en-US" dirty="0"/>
+              <a:t> est simple : signaler les associations de </a:t>
+            </a:r>
+            <a:r>
+              <a:rPr lang="en-US" dirty="0" err="1"/>
+              <a:t>médicaments</a:t>
+            </a:r>
+            <a:r>
+              <a:rPr lang="en-US" dirty="0"/>
+              <a:t> à </a:t>
+            </a:r>
+            <a:r>
+              <a:rPr lang="en-US" dirty="0" err="1"/>
+              <a:t>risque</a:t>
+            </a:r>
+            <a:r>
+              <a:rPr lang="en-US" dirty="0"/>
+              <a:t>, les classer par </a:t>
+            </a:r>
+            <a:r>
+              <a:rPr lang="en-US" dirty="0" err="1"/>
+              <a:t>gravité</a:t>
+            </a:r>
+            <a:r>
+              <a:rPr lang="en-US" dirty="0"/>
+              <a:t>, et surtout </a:t>
+            </a:r>
+            <a:r>
+              <a:rPr lang="en-US" dirty="0" err="1"/>
+              <a:t>expliquer</a:t>
+            </a:r>
+            <a:r>
+              <a:rPr lang="en-US" dirty="0"/>
+              <a:t> </a:t>
+            </a:r>
+            <a:r>
+              <a:rPr lang="en-US" dirty="0" err="1"/>
+              <a:t>chaque</a:t>
+            </a:r>
+            <a:r>
+              <a:rPr lang="en-US" dirty="0"/>
+              <a:t> </a:t>
+            </a:r>
+            <a:r>
+              <a:rPr lang="en-US" dirty="0" err="1"/>
+              <a:t>alerte</a:t>
+            </a:r>
+            <a:r>
+              <a:rPr lang="en-US" dirty="0"/>
+              <a:t>.</a:t>
+            </a:r>
+            <a:br>
+              <a:rPr lang="en-US" dirty="0">
+                <a:cs typeface="+mn-lt"/>
+              </a:rPr>
+            </a:br>
+            <a:r>
+              <a:rPr lang="en-US" dirty="0" err="1"/>
+              <a:t>Précisons</a:t>
+            </a:r>
+            <a:r>
+              <a:rPr lang="en-US" dirty="0"/>
+              <a:t>-le </a:t>
+            </a:r>
+            <a:r>
+              <a:rPr lang="en-US" dirty="0" err="1"/>
+              <a:t>dès</a:t>
+            </a:r>
+            <a:r>
+              <a:rPr lang="en-US" dirty="0"/>
+              <a:t> le </a:t>
+            </a:r>
+            <a:r>
+              <a:rPr lang="en-US" dirty="0" err="1"/>
+              <a:t>départ</a:t>
+            </a:r>
+            <a:r>
+              <a:rPr lang="en-US" dirty="0"/>
+              <a:t> : </a:t>
+            </a:r>
+            <a:r>
+              <a:rPr lang="en-US" dirty="0" err="1"/>
+              <a:t>c’est</a:t>
+            </a:r>
+            <a:r>
+              <a:rPr lang="en-US" dirty="0"/>
+              <a:t> un prototype </a:t>
+            </a:r>
+            <a:r>
+              <a:rPr lang="en-US" dirty="0" err="1"/>
+              <a:t>pédagogique</a:t>
+            </a:r>
+            <a:r>
+              <a:rPr lang="en-US" dirty="0"/>
+              <a:t>, il ne </a:t>
+            </a:r>
+            <a:r>
+              <a:rPr lang="en-US" dirty="0" err="1"/>
+              <a:t>remplace</a:t>
+            </a:r>
+            <a:r>
+              <a:rPr lang="en-US" dirty="0"/>
+              <a:t> pas </a:t>
+            </a:r>
+            <a:r>
+              <a:rPr lang="en-US" dirty="0" err="1"/>
+              <a:t>l’avis</a:t>
+            </a:r>
+            <a:r>
+              <a:rPr lang="en-US" dirty="0"/>
+              <a:t> d’un </a:t>
+            </a:r>
+            <a:r>
+              <a:rPr lang="en-US" dirty="0" err="1"/>
+              <a:t>pharmacien</a:t>
+            </a:r>
+            <a:r>
+              <a:rPr lang="en-US" dirty="0"/>
+              <a:t> </a:t>
+            </a:r>
+            <a:r>
+              <a:rPr lang="en-US" dirty="0" err="1"/>
+              <a:t>ou</a:t>
+            </a:r>
+            <a:r>
+              <a:rPr lang="en-US" dirty="0"/>
+              <a:t> d’un </a:t>
+            </a:r>
+            <a:r>
+              <a:rPr lang="en-US" dirty="0" err="1"/>
+              <a:t>médecin</a:t>
+            </a:r>
+            <a:r>
+              <a:rPr lang="en-US" dirty="0"/>
+              <a:t>.</a:t>
+            </a:r>
+            <a:endParaRPr lang="fr-FR" dirty="0"/>
+          </a:p>
+          <a:p>
+            <a:endParaRPr lang="fr-FR"/>
           </a:p>
         </p:txBody>
       </p:sp>
@@ -952,9 +1238,235 @@
           <a:lstStyle/>
           <a:p>
             <a:r>
-              <a:rPr lang="en-US" dirty="0"/>
-              <a:t>A + B. Phrase de fin : l'approche hybride gagne parce que les deux sources de connaissance se complètent, et l'évaluation croisée nous a appris à nous méfier d'un jeu de test écrit par l'auteur des règles.</a:t>
-            </a:r>
+              <a:rPr lang="en-US" b="1" dirty="0"/>
+              <a:t>Début :</a:t>
+            </a:r>
+            <a:r>
+              <a:rPr lang="en-US" dirty="0"/>
+              <a:t> Pour </a:t>
+            </a:r>
+            <a:r>
+              <a:rPr lang="en-US" dirty="0" err="1"/>
+              <a:t>conclure</a:t>
+            </a:r>
+            <a:r>
+              <a:rPr lang="en-US" dirty="0"/>
+              <a:t>, </a:t>
+            </a:r>
+            <a:r>
+              <a:rPr lang="en-US" dirty="0" err="1"/>
+              <a:t>notre</a:t>
+            </a:r>
+            <a:r>
+              <a:rPr lang="en-US" dirty="0"/>
+              <a:t> apport principal est de combiner deux sources de </a:t>
+            </a:r>
+            <a:r>
+              <a:rPr lang="en-US" dirty="0" err="1"/>
+              <a:t>connaissance</a:t>
+            </a:r>
+            <a:r>
+              <a:rPr lang="en-US" dirty="0"/>
+              <a:t> : les </a:t>
+            </a:r>
+            <a:r>
+              <a:rPr lang="en-US" dirty="0" err="1"/>
+              <a:t>règles</a:t>
+            </a:r>
+            <a:r>
+              <a:rPr lang="en-US" dirty="0"/>
+              <a:t> </a:t>
+            </a:r>
+            <a:r>
+              <a:rPr lang="en-US" dirty="0" err="1"/>
+              <a:t>donnent</a:t>
+            </a:r>
+            <a:r>
+              <a:rPr lang="en-US" dirty="0"/>
+              <a:t> la </a:t>
+            </a:r>
+            <a:r>
+              <a:rPr lang="en-US" dirty="0" err="1"/>
+              <a:t>gravité</a:t>
+            </a:r>
+            <a:r>
+              <a:rPr lang="en-US" dirty="0"/>
+              <a:t> et la source, et le </a:t>
+            </a:r>
+            <a:r>
+              <a:rPr lang="en-US" dirty="0" err="1"/>
+              <a:t>graphe</a:t>
+            </a:r>
+            <a:r>
+              <a:rPr lang="en-US" dirty="0"/>
+              <a:t> </a:t>
+            </a:r>
+            <a:r>
+              <a:rPr lang="en-US" dirty="0" err="1"/>
+              <a:t>permet</a:t>
+            </a:r>
+            <a:r>
+              <a:rPr lang="en-US" dirty="0"/>
+              <a:t> de </a:t>
+            </a:r>
+            <a:r>
+              <a:rPr lang="en-US" dirty="0" err="1"/>
+              <a:t>généraliser</a:t>
+            </a:r>
+            <a:r>
+              <a:rPr lang="en-US" dirty="0"/>
+              <a:t> au-</a:t>
+            </a:r>
+            <a:r>
+              <a:rPr lang="en-US" dirty="0" err="1"/>
+              <a:t>delà</a:t>
+            </a:r>
+            <a:r>
+              <a:rPr lang="en-US" dirty="0"/>
+              <a:t> </a:t>
+            </a:r>
+            <a:r>
+              <a:rPr lang="en-US" dirty="0" err="1"/>
+              <a:t>d’une</a:t>
+            </a:r>
+            <a:r>
+              <a:rPr lang="en-US" dirty="0"/>
+              <a:t> simple </a:t>
+            </a:r>
+            <a:r>
+              <a:rPr lang="en-US" dirty="0" err="1"/>
+              <a:t>liste</a:t>
+            </a:r>
+            <a:r>
+              <a:rPr lang="en-US" dirty="0"/>
+              <a:t>.</a:t>
+            </a:r>
+            <a:br>
+              <a:rPr lang="en-US" dirty="0">
+                <a:cs typeface="+mn-lt"/>
+              </a:rPr>
+            </a:br>
+            <a:r>
+              <a:rPr lang="en-US" dirty="0"/>
+              <a:t>(Aziz </a:t>
+            </a:r>
+            <a:r>
+              <a:rPr lang="en-US" dirty="0" err="1"/>
+              <a:t>donne</a:t>
+            </a:r>
+            <a:r>
+              <a:rPr lang="en-US" dirty="0"/>
+              <a:t> les chiffres.)</a:t>
+            </a:r>
+            <a:br>
+              <a:rPr lang="en-US" dirty="0">
+                <a:cs typeface="+mn-lt"/>
+              </a:rPr>
+            </a:br>
+            <a:r>
+              <a:rPr lang="en-US" dirty="0"/>
+              <a:t>Fin : Nous </a:t>
+            </a:r>
+            <a:r>
+              <a:rPr lang="en-US" dirty="0" err="1"/>
+              <a:t>insistons</a:t>
+            </a:r>
+            <a:r>
+              <a:rPr lang="en-US" dirty="0"/>
+              <a:t> sur le fait </a:t>
+            </a:r>
+            <a:r>
+              <a:rPr lang="en-US" dirty="0" err="1"/>
+              <a:t>que</a:t>
+            </a:r>
+            <a:r>
+              <a:rPr lang="en-US" dirty="0"/>
+              <a:t> </a:t>
+            </a:r>
+            <a:r>
+              <a:rPr lang="en-US" dirty="0" err="1"/>
+              <a:t>c’est</a:t>
+            </a:r>
+            <a:r>
+              <a:rPr lang="en-US" dirty="0"/>
+              <a:t> un prototype </a:t>
+            </a:r>
+            <a:r>
+              <a:rPr lang="en-US" dirty="0" err="1"/>
+              <a:t>pédagogique</a:t>
+            </a:r>
+            <a:r>
+              <a:rPr lang="en-US" dirty="0"/>
+              <a:t> : </a:t>
+            </a:r>
+            <a:r>
+              <a:rPr lang="en-US" dirty="0" err="1"/>
+              <a:t>une</a:t>
+            </a:r>
+            <a:r>
+              <a:rPr lang="en-US" dirty="0"/>
+              <a:t> validation par un </a:t>
+            </a:r>
+            <a:r>
+              <a:rPr lang="en-US" dirty="0" err="1"/>
+              <a:t>professionnel</a:t>
+            </a:r>
+            <a:r>
+              <a:rPr lang="en-US" dirty="0"/>
+              <a:t> de santé </a:t>
+            </a:r>
+            <a:r>
+              <a:rPr lang="en-US" dirty="0" err="1"/>
+              <a:t>reste</a:t>
+            </a:r>
+            <a:r>
+              <a:rPr lang="en-US" dirty="0"/>
+              <a:t> indispensable. Merci pour </a:t>
+            </a:r>
+            <a:r>
+              <a:rPr lang="en-US" dirty="0" err="1"/>
+              <a:t>votre</a:t>
+            </a:r>
+            <a:r>
+              <a:rPr lang="en-US" dirty="0"/>
+              <a:t> attention, nous </a:t>
+            </a:r>
+            <a:r>
+              <a:rPr lang="en-US" dirty="0" err="1"/>
+              <a:t>sommes</a:t>
+            </a:r>
+            <a:r>
+              <a:rPr lang="en-US" dirty="0"/>
+              <a:t> </a:t>
+            </a:r>
+            <a:r>
+              <a:rPr lang="en-US" dirty="0" err="1"/>
+              <a:t>prêts</a:t>
+            </a:r>
+            <a:r>
+              <a:rPr lang="en-US" dirty="0"/>
+              <a:t> à </a:t>
+            </a:r>
+            <a:r>
+              <a:rPr lang="en-US" dirty="0" err="1"/>
+              <a:t>répondre</a:t>
+            </a:r>
+            <a:r>
+              <a:rPr lang="en-US" dirty="0"/>
+              <a:t> à </a:t>
+            </a:r>
+            <a:r>
+              <a:rPr lang="en-US" dirty="0" err="1"/>
+              <a:t>vos</a:t>
+            </a:r>
+            <a:r>
+              <a:rPr lang="en-US" dirty="0"/>
+              <a:t> questions.</a:t>
+            </a:r>
+            <a:endParaRPr lang="fr-FR" dirty="0"/>
+          </a:p>
+          <a:p>
+            <a:endParaRPr lang="fr-FR"/>
           </a:p>
         </p:txBody>
       </p:sp>
@@ -1040,8 +1552,415 @@
           <a:p>
             <a:r>
               <a:rPr lang="en-US" dirty="0"/>
-              <a:t>A (Imane). Trois objectifs : détecter, hiérarchiser, expliquer. Le piège classique des systèmes d'aide à la prescription est la fatigue d'alerte : on mesurera donc la précision et le nombre d'alertes par ordonnance, pas seulement le rappel.</a:t>
-            </a:r>
+              <a:t>Une ordonnance </a:t>
+            </a:r>
+            <a:r>
+              <a:rPr lang="en-US" dirty="0" err="1"/>
+              <a:t>contient</a:t>
+            </a:r>
+            <a:r>
+              <a:rPr lang="en-US" dirty="0"/>
+              <a:t> </a:t>
+            </a:r>
+            <a:r>
+              <a:rPr lang="en-US" dirty="0" err="1"/>
+              <a:t>souvent</a:t>
+            </a:r>
+            <a:r>
+              <a:rPr lang="en-US" dirty="0"/>
+              <a:t> </a:t>
+            </a:r>
+            <a:r>
+              <a:rPr lang="en-US" dirty="0" err="1"/>
+              <a:t>plusieurs</a:t>
+            </a:r>
+            <a:r>
+              <a:rPr lang="en-US" dirty="0"/>
+              <a:t> </a:t>
+            </a:r>
+            <a:r>
+              <a:rPr lang="en-US" dirty="0" err="1"/>
+              <a:t>médicaments</a:t>
+            </a:r>
+            <a:r>
+              <a:rPr lang="en-US" dirty="0"/>
+              <a:t>, et </a:t>
+            </a:r>
+            <a:r>
+              <a:rPr lang="en-US" dirty="0" err="1"/>
+              <a:t>certaines</a:t>
+            </a:r>
+            <a:r>
+              <a:rPr lang="en-US" dirty="0"/>
+              <a:t> associations </a:t>
+            </a:r>
+            <a:r>
+              <a:rPr lang="en-US" dirty="0" err="1"/>
+              <a:t>augmentent</a:t>
+            </a:r>
+            <a:r>
+              <a:rPr lang="en-US" dirty="0"/>
+              <a:t> des </a:t>
+            </a:r>
+            <a:r>
+              <a:rPr lang="en-US" dirty="0" err="1"/>
+              <a:t>risques</a:t>
+            </a:r>
+            <a:r>
+              <a:rPr lang="en-US" dirty="0"/>
+              <a:t> </a:t>
+            </a:r>
+            <a:r>
+              <a:rPr lang="en-US" dirty="0" err="1"/>
+              <a:t>comme</a:t>
+            </a:r>
+            <a:r>
+              <a:rPr lang="en-US" dirty="0"/>
+              <a:t> le </a:t>
+            </a:r>
+            <a:r>
+              <a:rPr lang="en-US" dirty="0" err="1"/>
+              <a:t>saignement</a:t>
+            </a:r>
+            <a:r>
+              <a:rPr lang="en-US" dirty="0"/>
+              <a:t>, </a:t>
+            </a:r>
+            <a:r>
+              <a:rPr lang="en-US" dirty="0" err="1"/>
+              <a:t>l’hyperkaliémie</a:t>
+            </a:r>
+            <a:r>
+              <a:rPr lang="en-US" dirty="0"/>
+              <a:t> </a:t>
+            </a:r>
+            <a:r>
+              <a:rPr lang="en-US" dirty="0" err="1"/>
+              <a:t>ou</a:t>
+            </a:r>
+            <a:r>
+              <a:rPr lang="en-US" dirty="0"/>
+              <a:t> la </a:t>
+            </a:r>
+            <a:r>
+              <a:rPr lang="en-US" dirty="0" err="1"/>
+              <a:t>toxicité</a:t>
+            </a:r>
+            <a:r>
+              <a:rPr lang="en-US" dirty="0"/>
+              <a:t>.</a:t>
+            </a:r>
+            <a:br>
+              <a:rPr lang="en-US" dirty="0">
+                <a:cs typeface="+mn-lt"/>
+              </a:rPr>
+            </a:br>
+            <a:r>
+              <a:rPr lang="en-US" dirty="0"/>
+              <a:t>Notre </a:t>
+            </a:r>
+            <a:r>
+              <a:rPr lang="en-US" dirty="0" err="1"/>
+              <a:t>système</a:t>
+            </a:r>
+            <a:r>
+              <a:rPr lang="en-US" dirty="0"/>
+              <a:t> doit </a:t>
+            </a:r>
+            <a:r>
+              <a:rPr lang="en-US" dirty="0" err="1"/>
+              <a:t>donc</a:t>
+            </a:r>
+            <a:r>
+              <a:rPr lang="en-US" dirty="0"/>
+              <a:t> faire trois choses : </a:t>
+            </a:r>
+            <a:r>
+              <a:rPr lang="en-US" dirty="0" err="1"/>
+              <a:t>détecter</a:t>
+            </a:r>
+            <a:r>
+              <a:rPr lang="en-US" dirty="0"/>
+              <a:t> </a:t>
+            </a:r>
+            <a:r>
+              <a:rPr lang="en-US" dirty="0" err="1"/>
+              <a:t>ces</a:t>
+            </a:r>
+            <a:r>
+              <a:rPr lang="en-US" dirty="0"/>
+              <a:t> associations, les </a:t>
+            </a:r>
+            <a:r>
+              <a:rPr lang="en-US" dirty="0" err="1"/>
+              <a:t>hiérarchiser</a:t>
+            </a:r>
+            <a:r>
+              <a:rPr lang="en-US" dirty="0"/>
+              <a:t> </a:t>
+            </a:r>
+            <a:r>
+              <a:rPr lang="en-US" dirty="0" err="1"/>
+              <a:t>selon</a:t>
+            </a:r>
+            <a:r>
+              <a:rPr lang="en-US" dirty="0"/>
+              <a:t> </a:t>
+            </a:r>
+            <a:r>
+              <a:rPr lang="en-US" dirty="0" err="1"/>
+              <a:t>l’échelle</a:t>
+            </a:r>
+            <a:r>
+              <a:rPr lang="en-US" dirty="0"/>
+              <a:t> de </a:t>
+            </a:r>
+            <a:r>
+              <a:rPr lang="en-US" dirty="0" err="1"/>
+              <a:t>gravité</a:t>
+            </a:r>
+            <a:r>
+              <a:rPr lang="en-US" dirty="0"/>
+              <a:t> de </a:t>
+            </a:r>
+            <a:r>
+              <a:rPr lang="en-US" dirty="0" err="1"/>
+              <a:t>l’ANSM</a:t>
+            </a:r>
+            <a:r>
+              <a:rPr lang="en-US" dirty="0"/>
+              <a:t>, de 1 à 4, et </a:t>
+            </a:r>
+            <a:r>
+              <a:rPr lang="en-US" dirty="0" err="1"/>
+              <a:t>expliquer</a:t>
+            </a:r>
+            <a:r>
+              <a:rPr lang="en-US" dirty="0"/>
+              <a:t> </a:t>
+            </a:r>
+            <a:r>
+              <a:rPr lang="en-US" dirty="0" err="1"/>
+              <a:t>chaque</a:t>
+            </a:r>
+            <a:r>
+              <a:rPr lang="en-US" dirty="0"/>
+              <a:t> </a:t>
+            </a:r>
+            <a:r>
+              <a:rPr lang="en-US" dirty="0" err="1"/>
+              <a:t>alerte</a:t>
+            </a:r>
+            <a:r>
+              <a:rPr lang="en-US" dirty="0"/>
+              <a:t> avec </a:t>
+            </a:r>
+            <a:r>
+              <a:rPr lang="en-US" dirty="0" err="1"/>
+              <a:t>sa</a:t>
+            </a:r>
+            <a:r>
+              <a:rPr lang="en-US" dirty="0"/>
+              <a:t> </a:t>
+            </a:r>
+            <a:r>
+              <a:rPr lang="en-US" dirty="0" err="1"/>
+              <a:t>règle</a:t>
+            </a:r>
+            <a:r>
+              <a:rPr lang="en-US" dirty="0"/>
+              <a:t>, </a:t>
+            </a:r>
+            <a:r>
+              <a:rPr lang="en-US" dirty="0" err="1"/>
+              <a:t>sa</a:t>
+            </a:r>
+            <a:r>
+              <a:rPr lang="en-US" dirty="0"/>
+              <a:t> source et </a:t>
+            </a:r>
+            <a:r>
+              <a:rPr lang="en-US" dirty="0" err="1"/>
+              <a:t>sa</a:t>
+            </a:r>
+            <a:r>
+              <a:rPr lang="en-US" dirty="0"/>
+              <a:t> </a:t>
+            </a:r>
+            <a:r>
+              <a:rPr lang="en-US" dirty="0" err="1"/>
+              <a:t>preuve</a:t>
+            </a:r>
+            <a:r>
+              <a:rPr lang="en-US" dirty="0"/>
+              <a:t>.</a:t>
+            </a:r>
+            <a:br>
+              <a:rPr lang="en-US" dirty="0">
+                <a:cs typeface="+mn-lt"/>
+              </a:rPr>
+            </a:br>
+            <a:r>
+              <a:rPr lang="en-US" dirty="0"/>
+              <a:t>La </a:t>
+            </a:r>
+            <a:r>
+              <a:rPr lang="en-US" dirty="0" err="1"/>
+              <a:t>difficulté</a:t>
+            </a:r>
+            <a:r>
+              <a:rPr lang="en-US" dirty="0"/>
+              <a:t>, </a:t>
+            </a:r>
+            <a:r>
+              <a:rPr lang="en-US" dirty="0" err="1"/>
+              <a:t>c’est</a:t>
+            </a:r>
+            <a:r>
+              <a:rPr lang="en-US" dirty="0"/>
+              <a:t> la fatigue </a:t>
+            </a:r>
+            <a:r>
+              <a:rPr lang="en-US" dirty="0" err="1"/>
+              <a:t>d’alerte</a:t>
+            </a:r>
+            <a:r>
+              <a:rPr lang="en-US" dirty="0"/>
+              <a:t> : </a:t>
+            </a:r>
+            <a:r>
+              <a:rPr lang="en-US" dirty="0" err="1"/>
+              <a:t>si</a:t>
+            </a:r>
+            <a:r>
+              <a:rPr lang="en-US" dirty="0"/>
+              <a:t> un </a:t>
+            </a:r>
+            <a:r>
+              <a:rPr lang="en-US" dirty="0" err="1"/>
+              <a:t>logiciel</a:t>
+            </a:r>
+            <a:r>
+              <a:rPr lang="en-US" dirty="0"/>
+              <a:t> </a:t>
+            </a:r>
+            <a:r>
+              <a:rPr lang="en-US" dirty="0" err="1"/>
+              <a:t>alerte</a:t>
+            </a:r>
+            <a:r>
+              <a:rPr lang="en-US" dirty="0"/>
+              <a:t> trop </a:t>
+            </a:r>
+            <a:r>
+              <a:rPr lang="en-US" dirty="0" err="1"/>
+              <a:t>souvent</a:t>
+            </a:r>
+            <a:r>
+              <a:rPr lang="en-US" dirty="0"/>
+              <a:t>, le </a:t>
+            </a:r>
+            <a:r>
+              <a:rPr lang="en-US" dirty="0" err="1"/>
+              <a:t>prescripteur</a:t>
+            </a:r>
+            <a:r>
+              <a:rPr lang="en-US" dirty="0"/>
+              <a:t> </a:t>
+            </a:r>
+            <a:r>
+              <a:rPr lang="en-US" dirty="0" err="1"/>
+              <a:t>finit</a:t>
+            </a:r>
+            <a:r>
+              <a:rPr lang="en-US" dirty="0"/>
+              <a:t> par ignorer </a:t>
+            </a:r>
+            <a:r>
+              <a:rPr lang="en-US" dirty="0" err="1"/>
+              <a:t>toutes</a:t>
+            </a:r>
+            <a:r>
+              <a:rPr lang="en-US" dirty="0"/>
+              <a:t> les </a:t>
+            </a:r>
+            <a:r>
+              <a:rPr lang="en-US" dirty="0" err="1"/>
+              <a:t>alertes</a:t>
+            </a:r>
+            <a:r>
+              <a:rPr lang="en-US" dirty="0"/>
+              <a:t>, </a:t>
+            </a:r>
+            <a:r>
+              <a:rPr lang="en-US" dirty="0" err="1"/>
+              <a:t>même</a:t>
+            </a:r>
+            <a:r>
+              <a:rPr lang="en-US" dirty="0"/>
+              <a:t> les plus graves.</a:t>
+            </a:r>
+            <a:br>
+              <a:rPr lang="en-US" dirty="0">
+                <a:cs typeface="+mn-lt"/>
+              </a:rPr>
+            </a:br>
+            <a:r>
+              <a:rPr lang="en-US" dirty="0"/>
+              <a:t>Pour </a:t>
+            </a:r>
+            <a:r>
+              <a:rPr lang="en-US" dirty="0" err="1"/>
+              <a:t>connaître</a:t>
+            </a:r>
+            <a:r>
+              <a:rPr lang="en-US" dirty="0"/>
+              <a:t> les </a:t>
+            </a:r>
+            <a:r>
+              <a:rPr lang="en-US" dirty="0" err="1"/>
+              <a:t>médicaments</a:t>
+            </a:r>
+            <a:r>
+              <a:rPr lang="en-US" dirty="0"/>
+              <a:t>, nous </a:t>
+            </a:r>
+            <a:r>
+              <a:rPr lang="en-US" dirty="0" err="1"/>
+              <a:t>nous</a:t>
+            </a:r>
+            <a:r>
+              <a:rPr lang="en-US" dirty="0"/>
+              <a:t> </a:t>
+            </a:r>
+            <a:r>
+              <a:rPr lang="en-US" dirty="0" err="1"/>
+              <a:t>sommes</a:t>
+            </a:r>
+            <a:r>
+              <a:rPr lang="en-US" dirty="0"/>
+              <a:t> </a:t>
+            </a:r>
+            <a:r>
+              <a:rPr lang="en-US" dirty="0" err="1"/>
+              <a:t>appuyés</a:t>
+            </a:r>
+            <a:r>
+              <a:rPr lang="en-US" dirty="0"/>
+              <a:t> sur </a:t>
+            </a:r>
+            <a:r>
+              <a:rPr lang="en-US" dirty="0" err="1"/>
+              <a:t>Hetionet</a:t>
+            </a:r>
+            <a:r>
+              <a:rPr lang="en-US" dirty="0"/>
+              <a:t>.</a:t>
+            </a:r>
+            <a:endParaRPr lang="fr-FR" dirty="0"/>
+          </a:p>
+          <a:p>
+            <a:endParaRPr lang="fr-FR"/>
           </a:p>
         </p:txBody>
       </p:sp>
@@ -1126,9 +2045,540 @@
           <a:lstStyle/>
           <a:p>
             <a:r>
-              <a:rPr lang="en-US" dirty="0"/>
-              <a:t>A (Imane). Sous-graphe : 4 types d'arêtes (classe, cible, effet indésirable, maladie). Message clé : une absence d'arête n'est pas une absence de risque. C'est pour ça qu'on ajoute une table ATC et des synonymes.</a:t>
-            </a:r>
+              <a:rPr lang="en-US" dirty="0" err="1"/>
+              <a:t>Hetionet</a:t>
+            </a:r>
+            <a:r>
+              <a:rPr lang="en-US" dirty="0"/>
+              <a:t> est un </a:t>
+            </a:r>
+            <a:r>
+              <a:rPr lang="en-US" dirty="0" err="1"/>
+              <a:t>graphe</a:t>
+            </a:r>
+            <a:r>
+              <a:rPr lang="en-US" dirty="0"/>
+              <a:t> </a:t>
+            </a:r>
+            <a:r>
+              <a:rPr lang="en-US" dirty="0" err="1"/>
+              <a:t>biomédical</a:t>
+            </a:r>
+            <a:r>
+              <a:rPr lang="en-US" dirty="0"/>
+              <a:t> public. Sur </a:t>
+            </a:r>
+            <a:r>
+              <a:rPr lang="en-US" dirty="0" err="1"/>
+              <a:t>ses</a:t>
+            </a:r>
+            <a:r>
+              <a:rPr lang="en-US" dirty="0"/>
+              <a:t> 47 031 </a:t>
+            </a:r>
+            <a:r>
+              <a:rPr lang="en-US" dirty="0" err="1"/>
+              <a:t>nœuds</a:t>
+            </a:r>
+            <a:r>
+              <a:rPr lang="en-US" dirty="0"/>
+              <a:t>, nous </a:t>
+            </a:r>
+            <a:r>
+              <a:rPr lang="en-US" dirty="0" err="1"/>
+              <a:t>avons</a:t>
+            </a:r>
+            <a:r>
+              <a:rPr lang="en-US" dirty="0"/>
+              <a:t> </a:t>
+            </a:r>
+            <a:r>
+              <a:rPr lang="en-US" dirty="0" err="1"/>
+              <a:t>gardé</a:t>
+            </a:r>
+            <a:r>
+              <a:rPr lang="en-US" dirty="0"/>
+              <a:t> les 9 364 </a:t>
+            </a:r>
+            <a:r>
+              <a:rPr lang="en-US" dirty="0" err="1"/>
+              <a:t>utiles</a:t>
+            </a:r>
+            <a:r>
+              <a:rPr lang="en-US" dirty="0"/>
+              <a:t> à </a:t>
+            </a:r>
+            <a:r>
+              <a:rPr lang="en-US" dirty="0" err="1"/>
+              <a:t>notre</a:t>
+            </a:r>
+            <a:r>
+              <a:rPr lang="en-US" dirty="0"/>
+              <a:t> </a:t>
+            </a:r>
+            <a:r>
+              <a:rPr lang="en-US" dirty="0" err="1"/>
+              <a:t>problème</a:t>
+            </a:r>
+            <a:r>
+              <a:rPr lang="en-US" dirty="0"/>
+              <a:t> : les </a:t>
+            </a:r>
+            <a:r>
+              <a:rPr lang="en-US" dirty="0" err="1"/>
+              <a:t>médicaments</a:t>
+            </a:r>
+            <a:r>
+              <a:rPr lang="en-US" dirty="0"/>
+              <a:t>, </a:t>
+            </a:r>
+            <a:r>
+              <a:rPr lang="en-US" dirty="0" err="1"/>
+              <a:t>leurs</a:t>
+            </a:r>
+            <a:r>
+              <a:rPr lang="en-US" dirty="0"/>
+              <a:t> classes </a:t>
+            </a:r>
+            <a:r>
+              <a:rPr lang="en-US" dirty="0" err="1"/>
+              <a:t>pharmacologiques</a:t>
+            </a:r>
+            <a:r>
+              <a:rPr lang="en-US" dirty="0"/>
+              <a:t>, </a:t>
+            </a:r>
+            <a:r>
+              <a:rPr lang="en-US" dirty="0" err="1"/>
+              <a:t>leurs</a:t>
+            </a:r>
+            <a:r>
+              <a:rPr lang="en-US" dirty="0"/>
+              <a:t> </a:t>
+            </a:r>
+            <a:r>
+              <a:rPr lang="en-US" dirty="0" err="1"/>
+              <a:t>cibles</a:t>
+            </a:r>
+            <a:r>
+              <a:rPr lang="en-US" dirty="0"/>
+              <a:t> et </a:t>
+            </a:r>
+            <a:r>
+              <a:rPr lang="en-US" dirty="0" err="1"/>
+              <a:t>leurs</a:t>
+            </a:r>
+            <a:r>
+              <a:rPr lang="en-US" dirty="0"/>
+              <a:t> </a:t>
+            </a:r>
+            <a:r>
+              <a:rPr lang="en-US" dirty="0" err="1"/>
+              <a:t>effets</a:t>
+            </a:r>
+            <a:r>
+              <a:rPr lang="en-US" dirty="0"/>
+              <a:t> </a:t>
+            </a:r>
+            <a:r>
+              <a:rPr lang="en-US" dirty="0" err="1"/>
+              <a:t>indésirables</a:t>
+            </a:r>
+            <a:r>
+              <a:rPr lang="en-US" dirty="0"/>
+              <a:t>.</a:t>
+            </a:r>
+            <a:br>
+              <a:rPr lang="en-US" dirty="0">
+                <a:cs typeface="+mn-lt"/>
+              </a:rPr>
+            </a:br>
+            <a:r>
+              <a:rPr lang="en-US" dirty="0"/>
+              <a:t>Mais </a:t>
+            </a:r>
+            <a:r>
+              <a:rPr lang="en-US" dirty="0" err="1"/>
+              <a:t>ce</a:t>
+            </a:r>
+            <a:r>
+              <a:rPr lang="en-US" dirty="0"/>
+              <a:t> </a:t>
+            </a:r>
+            <a:r>
+              <a:rPr lang="en-US" dirty="0" err="1"/>
+              <a:t>graphe</a:t>
+            </a:r>
+            <a:r>
+              <a:rPr lang="en-US" dirty="0"/>
+              <a:t> est </a:t>
+            </a:r>
+            <a:r>
+              <a:rPr lang="en-US" dirty="0" err="1"/>
+              <a:t>incomplet</a:t>
+            </a:r>
+            <a:r>
+              <a:rPr lang="en-US" dirty="0"/>
+              <a:t> pour </a:t>
+            </a:r>
+            <a:r>
+              <a:rPr lang="en-US" dirty="0" err="1"/>
+              <a:t>notre</a:t>
+            </a:r>
+            <a:r>
+              <a:rPr lang="en-US" dirty="0"/>
+              <a:t> usage. </a:t>
+            </a:r>
+            <a:r>
+              <a:rPr lang="en-US" dirty="0" err="1"/>
+              <a:t>Seulement</a:t>
+            </a:r>
+            <a:r>
+              <a:rPr lang="en-US" dirty="0"/>
+              <a:t> 47 % des </a:t>
+            </a:r>
+            <a:r>
+              <a:rPr lang="en-US" dirty="0" err="1"/>
+              <a:t>médicaments</a:t>
+            </a:r>
+            <a:r>
+              <a:rPr lang="en-US" dirty="0"/>
+              <a:t> y </a:t>
+            </a:r>
+            <a:r>
+              <a:rPr lang="en-US" dirty="0" err="1"/>
+              <a:t>ont</a:t>
+            </a:r>
+            <a:r>
+              <a:rPr lang="en-US" dirty="0"/>
+              <a:t> </a:t>
+            </a:r>
+            <a:r>
+              <a:rPr lang="en-US" dirty="0" err="1"/>
+              <a:t>une</a:t>
+            </a:r>
+            <a:r>
+              <a:rPr lang="en-US" dirty="0"/>
+              <a:t> </a:t>
+            </a:r>
+            <a:r>
+              <a:rPr lang="en-US" dirty="0" err="1"/>
+              <a:t>classe</a:t>
+            </a:r>
+            <a:r>
+              <a:rPr lang="en-US" dirty="0"/>
+              <a:t> : les </a:t>
+            </a:r>
+            <a:r>
+              <a:rPr lang="en-US" dirty="0" err="1"/>
+              <a:t>statines</a:t>
+            </a:r>
+            <a:r>
+              <a:rPr lang="en-US" dirty="0"/>
+              <a:t>, les IEC </a:t>
+            </a:r>
+            <a:r>
+              <a:rPr lang="en-US" dirty="0" err="1"/>
+              <a:t>ou</a:t>
+            </a:r>
+            <a:r>
+              <a:rPr lang="en-US" dirty="0"/>
+              <a:t> le potassium </a:t>
+            </a:r>
+            <a:r>
+              <a:rPr lang="en-US" dirty="0" err="1"/>
+              <a:t>n’en</a:t>
+            </a:r>
+            <a:r>
+              <a:rPr lang="en-US" dirty="0"/>
+              <a:t> </a:t>
+            </a:r>
+            <a:r>
+              <a:rPr lang="en-US" dirty="0" err="1"/>
+              <a:t>ont</a:t>
+            </a:r>
+            <a:r>
+              <a:rPr lang="en-US" dirty="0"/>
+              <a:t> pas. Et la </a:t>
+            </a:r>
+            <a:r>
+              <a:rPr lang="en-US" dirty="0" err="1"/>
+              <a:t>warfarine</a:t>
+            </a:r>
+            <a:r>
+              <a:rPr lang="en-US" dirty="0"/>
+              <a:t>, un anticoagulant très à </a:t>
+            </a:r>
+            <a:r>
+              <a:rPr lang="en-US" dirty="0" err="1"/>
+              <a:t>risque</a:t>
+            </a:r>
+            <a:r>
+              <a:rPr lang="en-US" dirty="0"/>
+              <a:t>, </a:t>
+            </a:r>
+            <a:r>
+              <a:rPr lang="en-US" dirty="0" err="1"/>
+              <a:t>n’a</a:t>
+            </a:r>
+            <a:r>
+              <a:rPr lang="en-US" dirty="0"/>
+              <a:t> </a:t>
+            </a:r>
+            <a:r>
+              <a:rPr lang="en-US" dirty="0" err="1"/>
+              <a:t>aucun</a:t>
+            </a:r>
+            <a:r>
+              <a:rPr lang="en-US" dirty="0"/>
+              <a:t> </a:t>
+            </a:r>
+            <a:r>
+              <a:rPr lang="en-US" dirty="0" err="1"/>
+              <a:t>effet</a:t>
+            </a:r>
+            <a:r>
+              <a:rPr lang="en-US" dirty="0"/>
+              <a:t> </a:t>
+            </a:r>
+            <a:r>
+              <a:rPr lang="en-US" dirty="0" err="1"/>
+              <a:t>indésirable</a:t>
+            </a:r>
+            <a:r>
+              <a:rPr lang="en-US" dirty="0"/>
+              <a:t> dans le </a:t>
+            </a:r>
+            <a:r>
+              <a:rPr lang="en-US" dirty="0" err="1"/>
+              <a:t>graphe</a:t>
+            </a:r>
+            <a:r>
+              <a:rPr lang="en-US" dirty="0"/>
+              <a:t>.</a:t>
+            </a:r>
+            <a:br>
+              <a:rPr lang="en-US" dirty="0">
+                <a:cs typeface="+mn-lt"/>
+              </a:rPr>
+            </a:br>
+            <a:r>
+              <a:rPr lang="en-US" dirty="0"/>
+              <a:t>Nous </a:t>
+            </a:r>
+            <a:r>
+              <a:rPr lang="en-US" dirty="0" err="1"/>
+              <a:t>avons</a:t>
+            </a:r>
+            <a:r>
+              <a:rPr lang="en-US" dirty="0"/>
+              <a:t> </a:t>
+            </a:r>
+            <a:r>
+              <a:rPr lang="en-US" dirty="0" err="1"/>
+              <a:t>donc</a:t>
+            </a:r>
+            <a:r>
+              <a:rPr lang="en-US" dirty="0"/>
+              <a:t> </a:t>
+            </a:r>
+            <a:r>
+              <a:rPr lang="en-US" dirty="0" err="1"/>
+              <a:t>ajouté</a:t>
+            </a:r>
+            <a:r>
+              <a:rPr lang="en-US" dirty="0"/>
+              <a:t> </a:t>
+            </a:r>
+            <a:r>
+              <a:rPr lang="en-US" dirty="0" err="1"/>
+              <a:t>nos</a:t>
+            </a:r>
+            <a:r>
+              <a:rPr lang="en-US" dirty="0"/>
+              <a:t> </a:t>
+            </a:r>
+            <a:r>
+              <a:rPr lang="en-US" dirty="0" err="1"/>
+              <a:t>propres</a:t>
+            </a:r>
+            <a:r>
+              <a:rPr lang="en-US" dirty="0"/>
+              <a:t> </a:t>
+            </a:r>
+            <a:r>
+              <a:rPr lang="en-US" dirty="0" err="1"/>
+              <a:t>connaissances</a:t>
+            </a:r>
+            <a:r>
+              <a:rPr lang="en-US" dirty="0"/>
+              <a:t>, </a:t>
+            </a:r>
+            <a:r>
+              <a:rPr lang="en-US" dirty="0" err="1"/>
+              <a:t>toutes</a:t>
+            </a:r>
+            <a:r>
+              <a:rPr lang="en-US" dirty="0"/>
+              <a:t> </a:t>
+            </a:r>
+            <a:r>
+              <a:rPr lang="en-US" dirty="0" err="1"/>
+              <a:t>sourcées</a:t>
+            </a:r>
+            <a:r>
+              <a:rPr lang="en-US" dirty="0"/>
+              <a:t> : </a:t>
+            </a:r>
+            <a:r>
+              <a:rPr lang="en-US" dirty="0" err="1"/>
+              <a:t>une</a:t>
+            </a:r>
+            <a:r>
+              <a:rPr lang="en-US" dirty="0"/>
+              <a:t> table de 28 classes issue de la classification ATC de </a:t>
+            </a:r>
+            <a:r>
+              <a:rPr lang="en-US" dirty="0" err="1"/>
+              <a:t>l’OMS</a:t>
+            </a:r>
+            <a:r>
+              <a:rPr lang="en-US" dirty="0"/>
+              <a:t>, un </a:t>
+            </a:r>
+            <a:r>
+              <a:rPr lang="en-US" dirty="0" err="1"/>
+              <a:t>dictionnaire</a:t>
+            </a:r>
+            <a:r>
+              <a:rPr lang="en-US" dirty="0"/>
+              <a:t> de </a:t>
+            </a:r>
+            <a:r>
+              <a:rPr lang="en-US" dirty="0" err="1"/>
+              <a:t>synonymes</a:t>
+            </a:r>
+            <a:r>
+              <a:rPr lang="en-US" dirty="0"/>
+              <a:t> pour les noms français et </a:t>
+            </a:r>
+            <a:r>
+              <a:rPr lang="en-US" dirty="0" err="1"/>
+              <a:t>commerciaux</a:t>
+            </a:r>
+            <a:r>
+              <a:rPr lang="en-US" dirty="0"/>
+              <a:t>, </a:t>
+            </a:r>
+            <a:r>
+              <a:rPr lang="en-US" dirty="0" err="1"/>
+              <a:t>une</a:t>
+            </a:r>
+            <a:r>
+              <a:rPr lang="en-US" dirty="0"/>
+              <a:t> </a:t>
+            </a:r>
+            <a:r>
+              <a:rPr lang="en-US" dirty="0" err="1"/>
+              <a:t>liste</a:t>
+            </a:r>
+            <a:r>
+              <a:rPr lang="en-US" dirty="0"/>
+              <a:t> de 17 </a:t>
+            </a:r>
+            <a:r>
+              <a:rPr lang="en-US" dirty="0" err="1"/>
+              <a:t>effets</a:t>
+            </a:r>
+            <a:r>
+              <a:rPr lang="en-US" dirty="0"/>
+              <a:t> graves et 14 </a:t>
+            </a:r>
+            <a:r>
+              <a:rPr lang="en-US" dirty="0" err="1"/>
+              <a:t>médicaments</a:t>
+            </a:r>
+            <a:r>
+              <a:rPr lang="en-US" dirty="0"/>
+              <a:t> à marge </a:t>
+            </a:r>
+            <a:r>
+              <a:rPr lang="en-US" dirty="0" err="1"/>
+              <a:t>thérapeutique</a:t>
+            </a:r>
+            <a:r>
+              <a:rPr lang="en-US" dirty="0"/>
+              <a:t> </a:t>
+            </a:r>
+            <a:r>
+              <a:rPr lang="en-US" dirty="0" err="1"/>
+              <a:t>étroite</a:t>
+            </a:r>
+            <a:r>
+              <a:rPr lang="en-US" dirty="0"/>
+              <a:t>.</a:t>
+            </a:r>
+            <a:br>
+              <a:rPr lang="en-US" dirty="0">
+                <a:cs typeface="+mn-lt"/>
+              </a:rPr>
+            </a:br>
+            <a:r>
+              <a:rPr lang="en-US" dirty="0"/>
+              <a:t>Le message </a:t>
+            </a:r>
+            <a:r>
+              <a:rPr lang="en-US" dirty="0" err="1"/>
+              <a:t>clé</a:t>
+            </a:r>
+            <a:r>
+              <a:rPr lang="en-US" dirty="0"/>
+              <a:t> : dans un </a:t>
+            </a:r>
+            <a:r>
+              <a:rPr lang="en-US" dirty="0" err="1"/>
+              <a:t>graphe</a:t>
+            </a:r>
+            <a:r>
+              <a:rPr lang="en-US" dirty="0"/>
+              <a:t>, </a:t>
+            </a:r>
+            <a:r>
+              <a:rPr lang="en-US" dirty="0" err="1"/>
+              <a:t>l’absence</a:t>
+            </a:r>
+            <a:r>
+              <a:rPr lang="en-US" dirty="0"/>
+              <a:t> d’un lien ne </a:t>
+            </a:r>
+            <a:r>
+              <a:rPr lang="en-US" dirty="0" err="1"/>
+              <a:t>veut</a:t>
+            </a:r>
+            <a:r>
+              <a:rPr lang="en-US" dirty="0"/>
+              <a:t> pas dire </a:t>
+            </a:r>
+            <a:r>
+              <a:rPr lang="en-US" dirty="0" err="1"/>
+              <a:t>l’absence</a:t>
+            </a:r>
+            <a:r>
+              <a:rPr lang="en-US" dirty="0"/>
+              <a:t> de </a:t>
+            </a:r>
+            <a:r>
+              <a:rPr lang="en-US" dirty="0" err="1"/>
+              <a:t>risque</a:t>
+            </a:r>
+            <a:r>
+              <a:rPr lang="en-US" dirty="0"/>
+              <a:t>.</a:t>
+            </a:r>
+            <a:endParaRPr lang="fr-FR" dirty="0"/>
+          </a:p>
+          <a:p>
+            <a:endParaRPr lang="fr-FR"/>
           </a:p>
         </p:txBody>
       </p:sp>
@@ -1213,9 +2663,453 @@
           <a:lstStyle/>
           <a:p>
             <a:r>
-              <a:rPr lang="en-US" dirty="0"/>
-              <a:t>A (Imane). Le flux : on reconnaît les noms (français, commerciaux, fautes de frappe signalées), on forme toutes les paires, on applique deux familles de règles, puis le filtre anti-fatigue. Un médicament inconnu est toujours signalé, jamais ignoré en silence.</a:t>
-            </a:r>
+              <a:rPr lang="en-US" dirty="0" err="1"/>
+              <a:t>Voici</a:t>
+            </a:r>
+            <a:r>
+              <a:rPr lang="en-US" dirty="0"/>
+              <a:t> le </a:t>
+            </a:r>
+            <a:r>
+              <a:rPr lang="en-US" dirty="0" err="1"/>
+              <a:t>fonctionnement</a:t>
+            </a:r>
+            <a:r>
+              <a:rPr lang="en-US" dirty="0"/>
+              <a:t> du </a:t>
+            </a:r>
+            <a:r>
+              <a:rPr lang="en-US" dirty="0" err="1"/>
+              <a:t>système</a:t>
+            </a:r>
+            <a:r>
+              <a:rPr lang="en-US" dirty="0"/>
+              <a:t>.</a:t>
+            </a:r>
+            <a:br>
+              <a:rPr lang="en-US" dirty="0">
+                <a:cs typeface="+mn-lt"/>
+              </a:rPr>
+            </a:br>
+            <a:r>
+              <a:rPr lang="en-US" dirty="0"/>
+              <a:t>Il </a:t>
+            </a:r>
+            <a:r>
+              <a:rPr lang="en-US" dirty="0" err="1"/>
+              <a:t>reçoit</a:t>
+            </a:r>
+            <a:r>
+              <a:rPr lang="en-US" dirty="0"/>
+              <a:t> </a:t>
+            </a:r>
+            <a:r>
+              <a:rPr lang="en-US" dirty="0" err="1"/>
+              <a:t>une</a:t>
+            </a:r>
+            <a:r>
+              <a:rPr lang="en-US" dirty="0"/>
+              <a:t> ordonnance et commence par </a:t>
+            </a:r>
+            <a:r>
+              <a:rPr lang="en-US" dirty="0" err="1"/>
+              <a:t>reconnaître</a:t>
+            </a:r>
+            <a:r>
+              <a:rPr lang="en-US" dirty="0"/>
+              <a:t> les noms des </a:t>
+            </a:r>
+            <a:r>
+              <a:rPr lang="en-US" dirty="0" err="1"/>
+              <a:t>médicaments</a:t>
+            </a:r>
+            <a:r>
+              <a:rPr lang="en-US" dirty="0"/>
+              <a:t>, y </a:t>
+            </a:r>
+            <a:r>
+              <a:rPr lang="en-US" dirty="0" err="1"/>
+              <a:t>compris</a:t>
+            </a:r>
+            <a:r>
+              <a:rPr lang="en-US" dirty="0"/>
+              <a:t> les noms </a:t>
+            </a:r>
+            <a:r>
+              <a:rPr lang="en-US" dirty="0" err="1"/>
+              <a:t>commerciaux</a:t>
+            </a:r>
+            <a:r>
+              <a:rPr lang="en-US" dirty="0"/>
+              <a:t> et les </a:t>
+            </a:r>
+            <a:r>
+              <a:rPr lang="en-US" dirty="0" err="1"/>
+              <a:t>fautes</a:t>
+            </a:r>
+            <a:r>
+              <a:rPr lang="en-US" dirty="0"/>
+              <a:t> de frappe, qui </a:t>
+            </a:r>
+            <a:r>
+              <a:rPr lang="en-US" dirty="0" err="1"/>
+              <a:t>sont</a:t>
+            </a:r>
+            <a:r>
+              <a:rPr lang="en-US" dirty="0"/>
+              <a:t> </a:t>
+            </a:r>
+            <a:r>
+              <a:rPr lang="en-US" dirty="0" err="1"/>
+              <a:t>signalées</a:t>
+            </a:r>
+            <a:r>
+              <a:rPr lang="en-US" dirty="0"/>
+              <a:t>.</a:t>
+            </a:r>
+            <a:br>
+              <a:rPr lang="en-US" dirty="0">
+                <a:cs typeface="+mn-lt"/>
+              </a:rPr>
+            </a:br>
+            <a:r>
+              <a:rPr lang="en-US" dirty="0"/>
+              <a:t>Il examine ensuite </a:t>
+            </a:r>
+            <a:r>
+              <a:rPr lang="en-US" dirty="0" err="1"/>
+              <a:t>chaque</a:t>
+            </a:r>
+            <a:r>
+              <a:rPr lang="en-US" dirty="0"/>
+              <a:t> </a:t>
+            </a:r>
+            <a:r>
+              <a:rPr lang="en-US" dirty="0" err="1"/>
+              <a:t>paire</a:t>
+            </a:r>
+            <a:r>
+              <a:rPr lang="en-US" dirty="0"/>
+              <a:t> de </a:t>
+            </a:r>
+            <a:r>
+              <a:rPr lang="en-US" dirty="0" err="1"/>
+              <a:t>médicaments</a:t>
+            </a:r>
+            <a:r>
+              <a:rPr lang="en-US" dirty="0"/>
+              <a:t> et </a:t>
+            </a:r>
+            <a:r>
+              <a:rPr lang="en-US" dirty="0" err="1"/>
+              <a:t>lui</a:t>
+            </a:r>
+            <a:r>
+              <a:rPr lang="en-US" dirty="0"/>
+              <a:t> applique deux </a:t>
+            </a:r>
+            <a:r>
+              <a:rPr lang="en-US" dirty="0" err="1"/>
+              <a:t>familles</a:t>
+            </a:r>
+            <a:r>
+              <a:rPr lang="en-US" dirty="0"/>
+              <a:t> de </a:t>
+            </a:r>
+            <a:r>
+              <a:rPr lang="en-US" dirty="0" err="1"/>
+              <a:t>règles</a:t>
+            </a:r>
+            <a:r>
+              <a:rPr lang="en-US" dirty="0"/>
+              <a:t> : des </a:t>
+            </a:r>
+            <a:r>
+              <a:rPr lang="en-US" dirty="0" err="1"/>
+              <a:t>règles</a:t>
+            </a:r>
+            <a:r>
+              <a:rPr lang="en-US" dirty="0"/>
+              <a:t> </a:t>
+            </a:r>
+            <a:r>
+              <a:rPr lang="en-US" dirty="0" err="1"/>
+              <a:t>expertes</a:t>
+            </a:r>
+            <a:r>
+              <a:rPr lang="en-US" dirty="0"/>
+              <a:t>, et des </a:t>
+            </a:r>
+            <a:r>
+              <a:rPr lang="en-US" dirty="0" err="1"/>
+              <a:t>règles</a:t>
+            </a:r>
+            <a:r>
+              <a:rPr lang="en-US" dirty="0"/>
+              <a:t> qui </a:t>
+            </a:r>
+            <a:r>
+              <a:rPr lang="en-US" dirty="0" err="1"/>
+              <a:t>exploitent</a:t>
+            </a:r>
+            <a:r>
+              <a:rPr lang="en-US" dirty="0"/>
+              <a:t> </a:t>
+            </a:r>
+            <a:r>
+              <a:rPr lang="en-US" dirty="0" err="1"/>
+              <a:t>directement</a:t>
+            </a:r>
+            <a:r>
+              <a:rPr lang="en-US" dirty="0"/>
+              <a:t> le </a:t>
+            </a:r>
+            <a:r>
+              <a:rPr lang="en-US" dirty="0" err="1"/>
+              <a:t>graphe</a:t>
+            </a:r>
+            <a:r>
+              <a:rPr lang="en-US" dirty="0"/>
+              <a:t>.</a:t>
+            </a:r>
+            <a:br>
+              <a:rPr lang="en-US" dirty="0">
+                <a:cs typeface="+mn-lt"/>
+              </a:rPr>
+            </a:br>
+            <a:r>
+              <a:rPr lang="en-US" dirty="0"/>
+              <a:t>Vient ensuite le </a:t>
+            </a:r>
+            <a:r>
+              <a:rPr lang="en-US" dirty="0" err="1"/>
+              <a:t>filtre</a:t>
+            </a:r>
+            <a:r>
+              <a:rPr lang="en-US" dirty="0"/>
+              <a:t> anti-fatigue : les </a:t>
+            </a:r>
+            <a:r>
+              <a:rPr lang="en-US" dirty="0" err="1"/>
+              <a:t>règles</a:t>
+            </a:r>
+            <a:r>
+              <a:rPr lang="en-US" dirty="0"/>
+              <a:t> </a:t>
+            </a:r>
+            <a:r>
+              <a:rPr lang="en-US" dirty="0" err="1"/>
+              <a:t>expertes</a:t>
+            </a:r>
+            <a:r>
+              <a:rPr lang="en-US" dirty="0"/>
+              <a:t> </a:t>
+            </a:r>
+            <a:r>
+              <a:rPr lang="en-US" dirty="0" err="1"/>
+              <a:t>sont</a:t>
+            </a:r>
+            <a:r>
+              <a:rPr lang="en-US" dirty="0"/>
+              <a:t> </a:t>
+            </a:r>
+            <a:r>
+              <a:rPr lang="en-US" dirty="0" err="1"/>
+              <a:t>toujours</a:t>
+            </a:r>
+            <a:r>
+              <a:rPr lang="en-US" dirty="0"/>
+              <a:t> </a:t>
+            </a:r>
+            <a:r>
+              <a:rPr lang="en-US" dirty="0" err="1"/>
+              <a:t>affichées</a:t>
+            </a:r>
+            <a:r>
+              <a:rPr lang="en-US" dirty="0"/>
+              <a:t>, </a:t>
+            </a:r>
+            <a:r>
+              <a:rPr lang="en-US" dirty="0" err="1"/>
+              <a:t>mais</a:t>
+            </a:r>
+            <a:r>
+              <a:rPr lang="en-US" dirty="0"/>
+              <a:t> les </a:t>
+            </a:r>
+            <a:r>
+              <a:rPr lang="en-US" dirty="0" err="1"/>
+              <a:t>signaux</a:t>
+            </a:r>
+            <a:r>
+              <a:rPr lang="en-US" dirty="0"/>
+              <a:t> du </a:t>
+            </a:r>
+            <a:r>
+              <a:rPr lang="en-US" dirty="0" err="1"/>
+              <a:t>graphe</a:t>
+            </a:r>
+            <a:r>
+              <a:rPr lang="en-US" dirty="0"/>
+              <a:t> ne le </a:t>
+            </a:r>
+            <a:r>
+              <a:rPr lang="en-US" dirty="0" err="1"/>
+              <a:t>sont</a:t>
+            </a:r>
+            <a:r>
+              <a:rPr lang="en-US" dirty="0"/>
+              <a:t> </a:t>
+            </a:r>
+            <a:r>
+              <a:rPr lang="en-US" dirty="0" err="1"/>
+              <a:t>que</a:t>
+            </a:r>
+            <a:r>
+              <a:rPr lang="en-US" dirty="0"/>
+              <a:t> </a:t>
+            </a:r>
+            <a:r>
+              <a:rPr lang="en-US" dirty="0" err="1"/>
+              <a:t>s’ils</a:t>
+            </a:r>
+            <a:r>
+              <a:rPr lang="en-US" dirty="0"/>
+              <a:t> </a:t>
+            </a:r>
+            <a:r>
+              <a:rPr lang="en-US" dirty="0" err="1"/>
+              <a:t>atteignent</a:t>
+            </a:r>
+            <a:r>
+              <a:rPr lang="en-US" dirty="0"/>
+              <a:t> le </a:t>
+            </a:r>
+            <a:r>
+              <a:rPr lang="en-US" dirty="0" err="1"/>
+              <a:t>niveau</a:t>
+            </a:r>
+            <a:r>
+              <a:rPr lang="en-US" dirty="0"/>
+              <a:t> 2.</a:t>
+            </a:r>
+            <a:br>
+              <a:rPr lang="en-US" dirty="0">
+                <a:cs typeface="+mn-lt"/>
+              </a:rPr>
+            </a:br>
+            <a:r>
+              <a:rPr lang="en-US" dirty="0"/>
+              <a:t>À la fin, les </a:t>
+            </a:r>
+            <a:r>
+              <a:rPr lang="en-US" dirty="0" err="1"/>
+              <a:t>alertes</a:t>
+            </a:r>
+            <a:r>
+              <a:rPr lang="en-US" dirty="0"/>
+              <a:t> </a:t>
+            </a:r>
+            <a:r>
+              <a:rPr lang="en-US" dirty="0" err="1"/>
+              <a:t>sont</a:t>
+            </a:r>
+            <a:r>
+              <a:rPr lang="en-US" dirty="0"/>
+              <a:t> </a:t>
+            </a:r>
+            <a:r>
+              <a:rPr lang="en-US" dirty="0" err="1"/>
+              <a:t>triées</a:t>
+            </a:r>
+            <a:r>
+              <a:rPr lang="en-US" dirty="0"/>
+              <a:t> par </a:t>
+            </a:r>
+            <a:r>
+              <a:rPr lang="en-US" dirty="0" err="1"/>
+              <a:t>gravité</a:t>
+            </a:r>
+            <a:r>
+              <a:rPr lang="en-US" dirty="0"/>
+              <a:t>, </a:t>
+            </a:r>
+            <a:r>
+              <a:rPr lang="en-US" dirty="0" err="1"/>
+              <a:t>chacune</a:t>
+            </a:r>
+            <a:r>
+              <a:rPr lang="en-US" dirty="0"/>
+              <a:t> avec </a:t>
+            </a:r>
+            <a:r>
+              <a:rPr lang="en-US" dirty="0" err="1"/>
+              <a:t>sa</a:t>
+            </a:r>
+            <a:r>
+              <a:rPr lang="en-US" dirty="0"/>
+              <a:t> </a:t>
+            </a:r>
+            <a:r>
+              <a:rPr lang="en-US" dirty="0" err="1"/>
+              <a:t>règle</a:t>
+            </a:r>
+            <a:r>
+              <a:rPr lang="en-US" dirty="0"/>
+              <a:t>, </a:t>
+            </a:r>
+            <a:r>
+              <a:rPr lang="en-US" dirty="0" err="1"/>
+              <a:t>sa</a:t>
+            </a:r>
+            <a:r>
+              <a:rPr lang="en-US" dirty="0"/>
+              <a:t> source et son chemin dans le </a:t>
+            </a:r>
+            <a:r>
+              <a:rPr lang="en-US" dirty="0" err="1"/>
+              <a:t>graphe</a:t>
+            </a:r>
+            <a:r>
+              <a:rPr lang="en-US" dirty="0"/>
+              <a:t>. Et un </a:t>
+            </a:r>
+            <a:r>
+              <a:rPr lang="en-US" dirty="0" err="1"/>
+              <a:t>médicament</a:t>
+            </a:r>
+            <a:r>
+              <a:rPr lang="en-US" dirty="0"/>
+              <a:t> inconnu est </a:t>
+            </a:r>
+            <a:r>
+              <a:rPr lang="en-US" dirty="0" err="1"/>
+              <a:t>toujours</a:t>
+            </a:r>
+            <a:r>
+              <a:rPr lang="en-US" dirty="0"/>
+              <a:t> </a:t>
+            </a:r>
+            <a:r>
+              <a:rPr lang="en-US" dirty="0" err="1"/>
+              <a:t>signalé</a:t>
+            </a:r>
+            <a:r>
+              <a:rPr lang="en-US" dirty="0"/>
+              <a:t>, jamais </a:t>
+            </a:r>
+            <a:r>
+              <a:rPr lang="en-US" dirty="0" err="1"/>
+              <a:t>ignoré</a:t>
+            </a:r>
+            <a:r>
+              <a:rPr lang="en-US" dirty="0"/>
+              <a:t>.</a:t>
+            </a:r>
+            <a:endParaRPr lang="fr-FR" dirty="0"/>
+          </a:p>
+          <a:p>
+            <a:endParaRPr lang="fr-FR"/>
           </a:p>
         </p:txBody>
       </p:sp>
@@ -1300,9 +3194,473 @@
           <a:lstStyle/>
           <a:p>
             <a:r>
-              <a:rPr lang="en-US" dirty="0"/>
-              <a:t>B (Aziz) peut présenter R19-R24, qui viennent de sa version. Insister : la classe d'un médicament vient d'abord du graphe ; la table ATC ne sert que quand le graphe ne le classe pas. Les signaux G2/G3 sont trop fréquents pour être affichés seuls.</a:t>
-            </a:r>
+              <a:rPr lang="en-US" dirty="0" err="1"/>
+              <a:t>Concrètement</a:t>
+            </a:r>
+            <a:r>
+              <a:rPr lang="en-US" dirty="0"/>
+              <a:t>, nous </a:t>
+            </a:r>
+            <a:r>
+              <a:rPr lang="en-US" dirty="0" err="1"/>
+              <a:t>avons</a:t>
+            </a:r>
+            <a:r>
+              <a:rPr lang="en-US" dirty="0"/>
+              <a:t> 24 </a:t>
+            </a:r>
+            <a:r>
+              <a:rPr lang="en-US" dirty="0" err="1"/>
+              <a:t>règles</a:t>
+            </a:r>
+            <a:r>
+              <a:rPr lang="en-US" dirty="0"/>
+              <a:t> </a:t>
+            </a:r>
+            <a:r>
+              <a:rPr lang="en-US" dirty="0" err="1"/>
+              <a:t>expertes</a:t>
+            </a:r>
+            <a:r>
+              <a:rPr lang="en-US" dirty="0"/>
+              <a:t> et 3 </a:t>
+            </a:r>
+            <a:r>
+              <a:rPr lang="en-US" dirty="0" err="1"/>
+              <a:t>règles</a:t>
+            </a:r>
+            <a:r>
+              <a:rPr lang="en-US" dirty="0"/>
+              <a:t> issues du </a:t>
+            </a:r>
+            <a:r>
+              <a:rPr lang="en-US" dirty="0" err="1"/>
+              <a:t>graphe</a:t>
+            </a:r>
+            <a:r>
+              <a:rPr lang="en-US" dirty="0"/>
+              <a:t>.</a:t>
+            </a:r>
+            <a:br>
+              <a:rPr lang="en-US" dirty="0">
+                <a:cs typeface="+mn-lt"/>
+              </a:rPr>
+            </a:br>
+            <a:r>
+              <a:rPr lang="en-US" dirty="0"/>
+              <a:t>Les </a:t>
+            </a:r>
+            <a:r>
+              <a:rPr lang="en-US" dirty="0" err="1"/>
+              <a:t>règles</a:t>
+            </a:r>
+            <a:r>
+              <a:rPr lang="en-US" dirty="0"/>
+              <a:t> R01 à R18 </a:t>
+            </a:r>
+            <a:r>
+              <a:rPr lang="en-US" dirty="0" err="1"/>
+              <a:t>couvrent</a:t>
+            </a:r>
+            <a:r>
+              <a:rPr lang="en-US" dirty="0"/>
+              <a:t> des associations </a:t>
+            </a:r>
+            <a:r>
+              <a:rPr lang="en-US" dirty="0" err="1"/>
+              <a:t>connues</a:t>
+            </a:r>
+            <a:r>
+              <a:rPr lang="en-US" dirty="0"/>
+              <a:t> entre classes : par </a:t>
+            </a:r>
+            <a:r>
+              <a:rPr lang="en-US" dirty="0" err="1"/>
+              <a:t>exemple</a:t>
+            </a:r>
+            <a:r>
+              <a:rPr lang="en-US" dirty="0"/>
+              <a:t> un anticoagulant AVK avec un anti-</a:t>
+            </a:r>
+            <a:r>
+              <a:rPr lang="en-US" dirty="0" err="1"/>
+              <a:t>inflammatoire</a:t>
+            </a:r>
+            <a:r>
+              <a:rPr lang="en-US" dirty="0"/>
+              <a:t>, </a:t>
+            </a:r>
+            <a:r>
+              <a:rPr lang="en-US" dirty="0" err="1"/>
+              <a:t>une</a:t>
+            </a:r>
+            <a:r>
+              <a:rPr lang="en-US" dirty="0"/>
+              <a:t> </a:t>
+            </a:r>
+            <a:r>
+              <a:rPr lang="en-US" dirty="0" err="1"/>
+              <a:t>statine</a:t>
+            </a:r>
+            <a:r>
+              <a:rPr lang="en-US" dirty="0"/>
+              <a:t> avec un </a:t>
+            </a:r>
+            <a:r>
+              <a:rPr lang="en-US" dirty="0" err="1"/>
+              <a:t>inhibiteur</a:t>
+            </a:r>
+            <a:r>
+              <a:rPr lang="en-US" dirty="0"/>
+              <a:t> du CYP3A4, </a:t>
+            </a:r>
+            <a:r>
+              <a:rPr lang="en-US" dirty="0" err="1"/>
+              <a:t>ou</a:t>
+            </a:r>
+            <a:r>
+              <a:rPr lang="en-US" dirty="0"/>
+              <a:t> un </a:t>
+            </a:r>
+            <a:r>
+              <a:rPr lang="en-US" dirty="0" err="1"/>
+              <a:t>dérivé</a:t>
+            </a:r>
+            <a:r>
+              <a:rPr lang="en-US" dirty="0"/>
+              <a:t> </a:t>
+            </a:r>
+            <a:r>
+              <a:rPr lang="en-US" dirty="0" err="1"/>
+              <a:t>nitré</a:t>
+            </a:r>
+            <a:r>
+              <a:rPr lang="en-US" dirty="0"/>
+              <a:t> avec le Viagra.</a:t>
+            </a:r>
+            <a:br>
+              <a:rPr lang="en-US" dirty="0">
+                <a:cs typeface="+mn-lt"/>
+              </a:rPr>
+            </a:br>
+            <a:r>
+              <a:rPr lang="en-US" dirty="0"/>
+              <a:t>(Aziz :) Les </a:t>
+            </a:r>
+            <a:r>
+              <a:rPr lang="en-US" dirty="0" err="1"/>
+              <a:t>règles</a:t>
+            </a:r>
+            <a:r>
+              <a:rPr lang="en-US" dirty="0"/>
+              <a:t> R19 à R24 </a:t>
+            </a:r>
+            <a:r>
+              <a:rPr lang="en-US" dirty="0" err="1"/>
+              <a:t>viennent</a:t>
+            </a:r>
+            <a:r>
+              <a:rPr lang="en-US" dirty="0"/>
+              <a:t> de ma version : </a:t>
+            </a:r>
+            <a:r>
+              <a:rPr lang="en-US" dirty="0" err="1"/>
+              <a:t>antidépresseurs</a:t>
+            </a:r>
+            <a:r>
+              <a:rPr lang="en-US" dirty="0"/>
+              <a:t> ISRS avec AINS </a:t>
+            </a:r>
+            <a:r>
+              <a:rPr lang="en-US" dirty="0" err="1"/>
+              <a:t>ou</a:t>
+            </a:r>
+            <a:r>
+              <a:rPr lang="en-US" dirty="0"/>
+              <a:t> anticoagulants, </a:t>
+            </a:r>
+            <a:r>
+              <a:rPr lang="en-US" dirty="0" err="1"/>
+              <a:t>digoxine</a:t>
+            </a:r>
+            <a:r>
+              <a:rPr lang="en-US" dirty="0"/>
+              <a:t> avec macrolides, et potassium avec les </a:t>
+            </a:r>
+            <a:r>
+              <a:rPr lang="en-US" dirty="0" err="1"/>
+              <a:t>diurétiques</a:t>
+            </a:r>
+            <a:r>
+              <a:rPr lang="en-US" dirty="0"/>
+              <a:t> </a:t>
+            </a:r>
+            <a:r>
+              <a:rPr lang="en-US" dirty="0" err="1"/>
+              <a:t>épargneurs</a:t>
+            </a:r>
+            <a:r>
+              <a:rPr lang="en-US" dirty="0"/>
+              <a:t>.</a:t>
+            </a:r>
+            <a:br>
+              <a:rPr lang="en-US" dirty="0">
+                <a:cs typeface="+mn-lt"/>
+              </a:rPr>
+            </a:br>
+            <a:r>
+              <a:rPr lang="en-US" dirty="0"/>
+              <a:t>Les </a:t>
+            </a:r>
+            <a:r>
+              <a:rPr lang="en-US" dirty="0" err="1"/>
+              <a:t>règles</a:t>
+            </a:r>
+            <a:r>
+              <a:rPr lang="en-US" dirty="0"/>
+              <a:t> du </a:t>
+            </a:r>
+            <a:r>
+              <a:rPr lang="en-US" dirty="0" err="1"/>
+              <a:t>graphe</a:t>
+            </a:r>
+            <a:r>
+              <a:rPr lang="en-US" dirty="0"/>
+              <a:t>, </a:t>
+            </a:r>
+            <a:r>
+              <a:rPr lang="en-US" dirty="0" err="1"/>
+              <a:t>elles</a:t>
+            </a:r>
+            <a:r>
+              <a:rPr lang="en-US" dirty="0"/>
+              <a:t>, </a:t>
+            </a:r>
+            <a:r>
+              <a:rPr lang="en-US" dirty="0" err="1"/>
+              <a:t>détectent</a:t>
+            </a:r>
+            <a:r>
+              <a:rPr lang="en-US" dirty="0"/>
+              <a:t> des </a:t>
+            </a:r>
+            <a:r>
+              <a:rPr lang="en-US" dirty="0" err="1"/>
+              <a:t>mécanismes</a:t>
+            </a:r>
+            <a:r>
+              <a:rPr lang="en-US" dirty="0"/>
+              <a:t>. La </a:t>
+            </a:r>
+            <a:r>
+              <a:rPr lang="en-US" dirty="0" err="1"/>
+              <a:t>règle</a:t>
+            </a:r>
+            <a:r>
+              <a:rPr lang="en-US" dirty="0"/>
+              <a:t> G1 </a:t>
+            </a:r>
+            <a:r>
+              <a:rPr lang="en-US" dirty="0" err="1"/>
+              <a:t>repère</a:t>
+            </a:r>
+            <a:r>
+              <a:rPr lang="en-US" dirty="0"/>
+              <a:t> un </a:t>
+            </a:r>
+            <a:r>
+              <a:rPr lang="en-US" dirty="0" err="1"/>
+              <a:t>médicament</a:t>
+            </a:r>
+            <a:r>
+              <a:rPr lang="en-US" dirty="0"/>
+              <a:t> qui </a:t>
+            </a:r>
+            <a:r>
+              <a:rPr lang="en-US" dirty="0" err="1"/>
+              <a:t>bloque</a:t>
+            </a:r>
+            <a:r>
+              <a:rPr lang="en-US" dirty="0"/>
+              <a:t> </a:t>
+            </a:r>
+            <a:r>
+              <a:rPr lang="en-US" dirty="0" err="1"/>
+              <a:t>l’enzyme</a:t>
+            </a:r>
+            <a:r>
+              <a:rPr lang="en-US" dirty="0"/>
+              <a:t> </a:t>
+            </a:r>
+            <a:r>
+              <a:rPr lang="en-US" dirty="0" err="1"/>
+              <a:t>dont</a:t>
+            </a:r>
+            <a:r>
+              <a:rPr lang="en-US" dirty="0"/>
+              <a:t> un </a:t>
+            </a:r>
+            <a:r>
+              <a:rPr lang="en-US" dirty="0" err="1"/>
+              <a:t>autre</a:t>
+            </a:r>
+            <a:r>
+              <a:rPr lang="en-US" dirty="0"/>
+              <a:t> </a:t>
+            </a:r>
+            <a:r>
+              <a:rPr lang="en-US" dirty="0" err="1"/>
+              <a:t>dépend</a:t>
+            </a:r>
+            <a:r>
+              <a:rPr lang="en-US" dirty="0"/>
+              <a:t> ; </a:t>
+            </a:r>
+            <a:r>
+              <a:rPr lang="en-US" dirty="0" err="1"/>
+              <a:t>elle</a:t>
+            </a:r>
+            <a:r>
+              <a:rPr lang="en-US" dirty="0"/>
+              <a:t> ne monte au </a:t>
+            </a:r>
+            <a:r>
+              <a:rPr lang="en-US" dirty="0" err="1"/>
+              <a:t>niveau</a:t>
+            </a:r>
+            <a:r>
+              <a:rPr lang="en-US" dirty="0"/>
+              <a:t> 2 </a:t>
+            </a:r>
+            <a:r>
+              <a:rPr lang="en-US" dirty="0" err="1"/>
+              <a:t>que</a:t>
+            </a:r>
+            <a:r>
+              <a:rPr lang="en-US" dirty="0"/>
+              <a:t> </a:t>
+            </a:r>
+            <a:r>
+              <a:rPr lang="en-US" dirty="0" err="1"/>
+              <a:t>si</a:t>
+            </a:r>
+            <a:r>
+              <a:rPr lang="en-US" dirty="0"/>
+              <a:t> le second est à marge </a:t>
+            </a:r>
+            <a:r>
+              <a:rPr lang="en-US" dirty="0" err="1"/>
+              <a:t>étroite</a:t>
+            </a:r>
+            <a:r>
+              <a:rPr lang="en-US" dirty="0"/>
+              <a:t>. G2 et G3, </a:t>
+            </a:r>
+            <a:r>
+              <a:rPr lang="en-US" dirty="0" err="1"/>
+              <a:t>effet</a:t>
+            </a:r>
+            <a:r>
+              <a:rPr lang="en-US" dirty="0"/>
+              <a:t> </a:t>
+            </a:r>
+            <a:r>
+              <a:rPr lang="en-US" dirty="0" err="1"/>
+              <a:t>ou</a:t>
+            </a:r>
+            <a:r>
+              <a:rPr lang="en-US" dirty="0"/>
+              <a:t> </a:t>
+            </a:r>
+            <a:r>
+              <a:rPr lang="en-US" dirty="0" err="1"/>
+              <a:t>cible</a:t>
+            </a:r>
+            <a:r>
+              <a:rPr lang="en-US" dirty="0"/>
+              <a:t> commune, </a:t>
+            </a:r>
+            <a:r>
+              <a:rPr lang="en-US" dirty="0" err="1"/>
+              <a:t>restent</a:t>
+            </a:r>
+            <a:r>
+              <a:rPr lang="en-US" dirty="0"/>
+              <a:t> des </a:t>
+            </a:r>
+            <a:r>
+              <a:rPr lang="en-US" dirty="0" err="1"/>
+              <a:t>signaux</a:t>
+            </a:r>
+            <a:r>
+              <a:rPr lang="en-US" dirty="0"/>
+              <a:t> </a:t>
+            </a:r>
+            <a:r>
+              <a:rPr lang="en-US" dirty="0" err="1"/>
+              <a:t>faibles</a:t>
+            </a:r>
+            <a:r>
+              <a:rPr lang="en-US" dirty="0"/>
+              <a:t>.</a:t>
+            </a:r>
+            <a:br>
+              <a:rPr lang="en-US" dirty="0">
+                <a:cs typeface="+mn-lt"/>
+              </a:rPr>
+            </a:br>
+            <a:r>
+              <a:rPr lang="en-US" dirty="0" err="1"/>
+              <a:t>Toutes</a:t>
+            </a:r>
+            <a:r>
+              <a:rPr lang="en-US" dirty="0"/>
+              <a:t> </a:t>
+            </a:r>
+            <a:r>
+              <a:rPr lang="en-US" dirty="0" err="1"/>
+              <a:t>nos</a:t>
+            </a:r>
+            <a:r>
+              <a:rPr lang="en-US" dirty="0"/>
+              <a:t> </a:t>
+            </a:r>
+            <a:r>
+              <a:rPr lang="en-US" dirty="0" err="1"/>
+              <a:t>règles</a:t>
+            </a:r>
+            <a:r>
+              <a:rPr lang="en-US" dirty="0"/>
+              <a:t> </a:t>
+            </a:r>
+            <a:r>
+              <a:rPr lang="en-US" dirty="0" err="1"/>
+              <a:t>sont</a:t>
+            </a:r>
+            <a:r>
+              <a:rPr lang="en-US" dirty="0"/>
+              <a:t> </a:t>
+            </a:r>
+            <a:r>
+              <a:rPr lang="en-US" dirty="0" err="1"/>
+              <a:t>sourcées</a:t>
+            </a:r>
+            <a:r>
+              <a:rPr lang="en-US" dirty="0"/>
+              <a:t> : </a:t>
+            </a:r>
+            <a:r>
+              <a:rPr lang="en-US" dirty="0" err="1"/>
+              <a:t>Thésaurus</a:t>
+            </a:r>
+            <a:r>
+              <a:rPr lang="en-US" dirty="0"/>
+              <a:t> ANSM, classification ATC, notices EMA et FDA.</a:t>
+            </a:r>
+            <a:endParaRPr lang="fr-FR" dirty="0"/>
+          </a:p>
+          <a:p>
+            <a:endParaRPr lang="fr-FR"/>
           </a:p>
         </p:txBody>
       </p:sp>
@@ -1387,9 +3745,354 @@
           <a:lstStyle/>
           <a:p>
             <a:r>
-              <a:rPr lang="en-US" dirty="0"/>
-              <a:t>Démo possible en direct. Montrer que 100 % des alertes portent une règle, une source et un chemin. Le même exemple avec Previscan + Advil montre l'intérêt des synonymes et de la table quand le graphe ne connaît pas le médicament.</a:t>
-            </a:r>
+              <a:rPr lang="en-US" dirty="0" err="1"/>
+              <a:t>Voici</a:t>
+            </a:r>
+            <a:r>
+              <a:rPr lang="en-US" dirty="0"/>
+              <a:t> un </a:t>
+            </a:r>
+            <a:r>
+              <a:rPr lang="en-US" dirty="0" err="1"/>
+              <a:t>exemple</a:t>
+            </a:r>
+            <a:r>
+              <a:rPr lang="en-US" dirty="0"/>
+              <a:t> </a:t>
+            </a:r>
+            <a:r>
+              <a:rPr lang="en-US" dirty="0" err="1"/>
+              <a:t>concret</a:t>
+            </a:r>
+            <a:r>
+              <a:rPr lang="en-US" dirty="0"/>
+              <a:t>. On </a:t>
+            </a:r>
+            <a:r>
+              <a:rPr lang="en-US" dirty="0" err="1"/>
+              <a:t>saisit</a:t>
+            </a:r>
+            <a:r>
+              <a:rPr lang="en-US" dirty="0"/>
+              <a:t> </a:t>
+            </a:r>
+            <a:r>
+              <a:rPr lang="en-US" dirty="0" err="1"/>
+              <a:t>warfarine</a:t>
+            </a:r>
+            <a:r>
+              <a:rPr lang="en-US" dirty="0"/>
+              <a:t>, </a:t>
+            </a:r>
+            <a:r>
+              <a:rPr lang="en-US" dirty="0" err="1"/>
+              <a:t>ibuprofène</a:t>
+            </a:r>
+            <a:r>
+              <a:rPr lang="en-US" dirty="0"/>
+              <a:t> et </a:t>
+            </a:r>
+            <a:r>
+              <a:rPr lang="en-US" dirty="0" err="1"/>
+              <a:t>oméprazole</a:t>
+            </a:r>
+            <a:r>
+              <a:rPr lang="en-US" dirty="0"/>
+              <a:t>.</a:t>
+            </a:r>
+            <a:br>
+              <a:rPr lang="en-US" dirty="0"/>
+            </a:br>
+            <a:r>
+              <a:rPr lang="en-US" dirty="0"/>
+              <a:t>Le </a:t>
+            </a:r>
+            <a:r>
+              <a:rPr lang="en-US" dirty="0" err="1"/>
+              <a:t>système</a:t>
+            </a:r>
+            <a:r>
+              <a:rPr lang="en-US" dirty="0"/>
+              <a:t> </a:t>
+            </a:r>
+            <a:r>
+              <a:rPr lang="en-US" dirty="0" err="1"/>
+              <a:t>détecte</a:t>
+            </a:r>
+            <a:r>
+              <a:rPr lang="en-US" dirty="0"/>
+              <a:t> </a:t>
+            </a:r>
+            <a:r>
+              <a:rPr lang="en-US" dirty="0" err="1"/>
+              <a:t>une</a:t>
+            </a:r>
+            <a:r>
+              <a:rPr lang="en-US" dirty="0"/>
+              <a:t> association </a:t>
+            </a:r>
+            <a:r>
+              <a:rPr lang="en-US" dirty="0" err="1"/>
+              <a:t>déconseillée</a:t>
+            </a:r>
+            <a:r>
+              <a:rPr lang="en-US" dirty="0"/>
+              <a:t> entre la </a:t>
+            </a:r>
+            <a:r>
+              <a:rPr lang="en-US" dirty="0" err="1"/>
+              <a:t>warfarine</a:t>
+            </a:r>
+            <a:r>
+              <a:rPr lang="en-US" dirty="0"/>
+              <a:t> et </a:t>
+            </a:r>
+            <a:r>
+              <a:rPr lang="en-US" dirty="0" err="1"/>
+              <a:t>l’ibuprofène</a:t>
+            </a:r>
+            <a:r>
+              <a:rPr lang="en-US" dirty="0"/>
+              <a:t> : </a:t>
+            </a:r>
+            <a:r>
+              <a:rPr lang="en-US" dirty="0" err="1"/>
+              <a:t>c’est</a:t>
+            </a:r>
+            <a:r>
+              <a:rPr lang="en-US" dirty="0"/>
+              <a:t> la </a:t>
+            </a:r>
+            <a:r>
+              <a:rPr lang="en-US" dirty="0" err="1"/>
+              <a:t>règle</a:t>
+            </a:r>
+            <a:r>
+              <a:rPr lang="en-US" dirty="0"/>
+              <a:t> R01, qui </a:t>
+            </a:r>
+            <a:r>
+              <a:rPr lang="en-US" dirty="0" err="1"/>
+              <a:t>signale</a:t>
+            </a:r>
+            <a:r>
+              <a:rPr lang="en-US" dirty="0"/>
+              <a:t> un </a:t>
+            </a:r>
+            <a:r>
+              <a:rPr lang="en-US" dirty="0" err="1"/>
+              <a:t>risque</a:t>
+            </a:r>
+            <a:r>
+              <a:rPr lang="en-US" dirty="0"/>
+              <a:t> de </a:t>
+            </a:r>
+            <a:r>
+              <a:rPr lang="en-US" dirty="0" err="1"/>
+              <a:t>saignement</a:t>
+            </a:r>
+            <a:r>
+              <a:rPr lang="en-US" dirty="0"/>
+              <a:t>.</a:t>
+            </a:r>
+            <a:br>
+              <a:rPr lang="en-US" dirty="0"/>
+            </a:br>
+            <a:r>
+              <a:rPr lang="en-US" dirty="0"/>
+              <a:t>Et il </a:t>
+            </a:r>
+            <a:r>
+              <a:rPr lang="en-US" dirty="0" err="1"/>
+              <a:t>explique</a:t>
+            </a:r>
+            <a:r>
+              <a:rPr lang="en-US" dirty="0"/>
+              <a:t> </a:t>
+            </a:r>
+            <a:r>
+              <a:rPr lang="en-US" dirty="0" err="1"/>
+              <a:t>pourquoi</a:t>
+            </a:r>
+            <a:r>
+              <a:rPr lang="en-US" dirty="0"/>
+              <a:t> : la </a:t>
+            </a:r>
+            <a:r>
+              <a:rPr lang="en-US" dirty="0" err="1"/>
+              <a:t>warfarine</a:t>
+            </a:r>
+            <a:r>
+              <a:rPr lang="en-US" dirty="0"/>
+              <a:t> </a:t>
+            </a:r>
+            <a:r>
+              <a:rPr lang="en-US" dirty="0" err="1"/>
+              <a:t>appartient</a:t>
+            </a:r>
+            <a:r>
+              <a:rPr lang="en-US" dirty="0"/>
+              <a:t> à la </a:t>
+            </a:r>
+            <a:r>
+              <a:rPr lang="en-US" dirty="0" err="1"/>
+              <a:t>classe</a:t>
+            </a:r>
+            <a:r>
+              <a:rPr lang="en-US" dirty="0"/>
+              <a:t> des </a:t>
+            </a:r>
+            <a:r>
+              <a:rPr lang="en-US" dirty="0" err="1"/>
+              <a:t>antivitamines</a:t>
+            </a:r>
+            <a:r>
+              <a:rPr lang="en-US" dirty="0"/>
+              <a:t> K, </a:t>
+            </a:r>
+            <a:r>
+              <a:rPr lang="en-US" dirty="0" err="1"/>
+              <a:t>l’ibuprofène</a:t>
+            </a:r>
+            <a:r>
+              <a:rPr lang="en-US" dirty="0"/>
+              <a:t> à </a:t>
+            </a:r>
+            <a:r>
+              <a:rPr lang="en-US" dirty="0" err="1"/>
+              <a:t>celle</a:t>
+            </a:r>
+            <a:r>
+              <a:rPr lang="en-US" dirty="0"/>
+              <a:t> des anti-</a:t>
+            </a:r>
+            <a:r>
+              <a:rPr lang="en-US" dirty="0" err="1"/>
+              <a:t>inflammatoires</a:t>
+            </a:r>
+            <a:r>
+              <a:rPr lang="en-US" dirty="0"/>
+              <a:t>, </a:t>
+            </a:r>
+            <a:r>
+              <a:rPr lang="en-US" dirty="0" err="1"/>
+              <a:t>selon</a:t>
+            </a:r>
+            <a:r>
+              <a:rPr lang="en-US" dirty="0"/>
+              <a:t> le </a:t>
+            </a:r>
+            <a:r>
+              <a:rPr lang="en-US" dirty="0" err="1"/>
+              <a:t>graphe</a:t>
+            </a:r>
+            <a:r>
+              <a:rPr lang="en-US" dirty="0"/>
+              <a:t>. La source est le </a:t>
+            </a:r>
+            <a:r>
+              <a:rPr lang="en-US" dirty="0" err="1"/>
+              <a:t>Thésaurus</a:t>
+            </a:r>
+            <a:r>
+              <a:rPr lang="en-US" dirty="0"/>
+              <a:t> de </a:t>
+            </a:r>
+            <a:r>
+              <a:rPr lang="en-US" dirty="0" err="1"/>
+              <a:t>l’ANSM</a:t>
+            </a:r>
+            <a:r>
+              <a:rPr lang="en-US" dirty="0"/>
+              <a:t>.</a:t>
+            </a:r>
+            <a:br>
+              <a:rPr lang="en-US" dirty="0"/>
+            </a:br>
+            <a:r>
+              <a:rPr lang="en-US" dirty="0" err="1"/>
+              <a:t>Autre</a:t>
+            </a:r>
+            <a:r>
+              <a:rPr lang="en-US" dirty="0"/>
+              <a:t> point fort : un </a:t>
+            </a:r>
+            <a:r>
+              <a:rPr lang="en-US" dirty="0" err="1"/>
+              <a:t>médicament</a:t>
+            </a:r>
+            <a:r>
+              <a:rPr lang="en-US" dirty="0"/>
+              <a:t> </a:t>
+            </a:r>
+            <a:r>
+              <a:rPr lang="en-US" dirty="0" err="1"/>
+              <a:t>comme</a:t>
+            </a:r>
+            <a:r>
+              <a:rPr lang="en-US" dirty="0"/>
+              <a:t> le </a:t>
+            </a:r>
+            <a:r>
+              <a:rPr lang="en-US" dirty="0" err="1"/>
+              <a:t>Previscan</a:t>
+            </a:r>
+            <a:r>
+              <a:rPr lang="en-US" dirty="0"/>
+              <a:t>, absent du </a:t>
+            </a:r>
+            <a:r>
+              <a:rPr lang="en-US" dirty="0" err="1"/>
+              <a:t>graphe</a:t>
+            </a:r>
+            <a:r>
+              <a:rPr lang="en-US" dirty="0"/>
+              <a:t>, est </a:t>
+            </a:r>
+            <a:r>
+              <a:rPr lang="en-US" dirty="0" err="1"/>
+              <a:t>quand</a:t>
+            </a:r>
+            <a:r>
+              <a:rPr lang="en-US" dirty="0"/>
+              <a:t> </a:t>
+            </a:r>
+            <a:r>
+              <a:rPr lang="en-US" dirty="0" err="1"/>
+              <a:t>même</a:t>
+            </a:r>
+            <a:r>
+              <a:rPr lang="en-US" dirty="0"/>
+              <a:t> </a:t>
+            </a:r>
+            <a:r>
+              <a:rPr lang="en-US" dirty="0" err="1"/>
+              <a:t>reconnu</a:t>
+            </a:r>
+            <a:r>
+              <a:rPr lang="en-US" dirty="0"/>
+              <a:t> et </a:t>
+            </a:r>
+            <a:r>
+              <a:rPr lang="en-US" dirty="0" err="1"/>
+              <a:t>classé</a:t>
+            </a:r>
+            <a:r>
+              <a:rPr lang="en-US" dirty="0"/>
+              <a:t> grâce à </a:t>
+            </a:r>
+            <a:r>
+              <a:rPr lang="en-US" dirty="0" err="1"/>
+              <a:t>notre</a:t>
+            </a:r>
+            <a:r>
+              <a:rPr lang="en-US" dirty="0"/>
+              <a:t> table ATC.</a:t>
+            </a:r>
+            <a:endParaRPr lang="fr-FR" dirty="0"/>
+          </a:p>
+          <a:p>
+            <a:endParaRPr lang="fr-FR"/>
           </a:p>
         </p:txBody>
       </p:sp>
@@ -1475,8 +4178,392 @@
           <a:p>
             <a:r>
               <a:rPr lang="en-US" dirty="0"/>
-              <a:t>B (Aziz). Chacun a écrit 20 ordonnances avec leurs paires attendues et leurs sources. La référence non hybride isole ce qu'apportent les classes et le graphe. Annoncer d'emblée le biais : celui qui écrit les règles écrit aussi le test.</a:t>
-            </a:r>
+              <a:t>Pour </a:t>
+            </a:r>
+            <a:r>
+              <a:rPr lang="en-US" dirty="0" err="1"/>
+              <a:t>évaluer</a:t>
+            </a:r>
+            <a:r>
+              <a:rPr lang="en-US" dirty="0"/>
+              <a:t> le </a:t>
+            </a:r>
+            <a:r>
+              <a:rPr lang="en-US" dirty="0" err="1"/>
+              <a:t>système</a:t>
+            </a:r>
+            <a:r>
+              <a:rPr lang="en-US" dirty="0"/>
+              <a:t>, nous </a:t>
+            </a:r>
+            <a:r>
+              <a:rPr lang="en-US" dirty="0" err="1"/>
+              <a:t>avons</a:t>
+            </a:r>
+            <a:r>
+              <a:rPr lang="en-US" dirty="0"/>
+              <a:t> </a:t>
+            </a:r>
+            <a:r>
+              <a:rPr lang="en-US" dirty="0" err="1"/>
+              <a:t>réuni</a:t>
+            </a:r>
+            <a:r>
+              <a:rPr lang="en-US" dirty="0"/>
+              <a:t> 40 ordonnances, 20 </a:t>
+            </a:r>
+            <a:r>
+              <a:rPr lang="en-US" dirty="0" err="1"/>
+              <a:t>écrites</a:t>
+            </a:r>
+            <a:r>
+              <a:rPr lang="en-US" dirty="0"/>
+              <a:t> par chacun de nous, avec 54 associations à </a:t>
+            </a:r>
+            <a:r>
+              <a:rPr lang="en-US" dirty="0" err="1"/>
+              <a:t>risque</a:t>
+            </a:r>
+            <a:r>
+              <a:rPr lang="en-US" dirty="0"/>
+              <a:t> </a:t>
+            </a:r>
+            <a:r>
+              <a:rPr lang="en-US" dirty="0" err="1"/>
+              <a:t>attendues</a:t>
+            </a:r>
+            <a:r>
+              <a:rPr lang="en-US" dirty="0"/>
+              <a:t>.</a:t>
+            </a:r>
+            <a:br>
+              <a:rPr lang="en-US" dirty="0">
+                <a:cs typeface="+mn-lt"/>
+              </a:rPr>
+            </a:br>
+            <a:r>
+              <a:rPr lang="en-US" dirty="0"/>
+              <a:t>Nous le </a:t>
+            </a:r>
+            <a:r>
+              <a:rPr lang="en-US" dirty="0" err="1"/>
+              <a:t>comparons</a:t>
+            </a:r>
+            <a:r>
+              <a:rPr lang="en-US" dirty="0"/>
+              <a:t> à </a:t>
+            </a:r>
+            <a:r>
+              <a:rPr lang="en-US" dirty="0" err="1"/>
+              <a:t>une</a:t>
+            </a:r>
+            <a:r>
+              <a:rPr lang="en-US" dirty="0"/>
+              <a:t> </a:t>
+            </a:r>
+            <a:r>
+              <a:rPr lang="en-US" dirty="0" err="1"/>
+              <a:t>référence</a:t>
+            </a:r>
+            <a:r>
+              <a:rPr lang="en-US" dirty="0"/>
+              <a:t> non </a:t>
+            </a:r>
+            <a:r>
+              <a:rPr lang="en-US" dirty="0" err="1"/>
+              <a:t>hybride</a:t>
+            </a:r>
+            <a:r>
+              <a:rPr lang="en-US" dirty="0"/>
+              <a:t> : </a:t>
+            </a:r>
+            <a:r>
+              <a:rPr lang="en-US" dirty="0" err="1"/>
+              <a:t>une</a:t>
+            </a:r>
+            <a:r>
+              <a:rPr lang="en-US" dirty="0"/>
+              <a:t> simple </a:t>
+            </a:r>
+            <a:r>
+              <a:rPr lang="en-US" dirty="0" err="1"/>
+              <a:t>liste</a:t>
+            </a:r>
+            <a:r>
+              <a:rPr lang="en-US" dirty="0"/>
+              <a:t> de 26 associations </a:t>
+            </a:r>
+            <a:r>
+              <a:rPr lang="en-US" dirty="0" err="1"/>
+              <a:t>connues</a:t>
+            </a:r>
+            <a:r>
+              <a:rPr lang="en-US" dirty="0"/>
+              <a:t>, sans </a:t>
+            </a:r>
+            <a:r>
+              <a:rPr lang="en-US" dirty="0" err="1"/>
+              <a:t>graphe</a:t>
+            </a:r>
+            <a:r>
+              <a:rPr lang="en-US" dirty="0"/>
+              <a:t> </a:t>
+            </a:r>
+            <a:r>
+              <a:rPr lang="en-US" dirty="0" err="1"/>
+              <a:t>ni</a:t>
+            </a:r>
+            <a:r>
+              <a:rPr lang="en-US" dirty="0"/>
+              <a:t> classes.</a:t>
+            </a:r>
+            <a:br>
+              <a:rPr lang="en-US" dirty="0">
+                <a:cs typeface="+mn-lt"/>
+              </a:rPr>
+            </a:br>
+            <a:r>
+              <a:rPr lang="en-US" dirty="0"/>
+              <a:t>Nous </a:t>
+            </a:r>
+            <a:r>
+              <a:rPr lang="en-US" dirty="0" err="1"/>
+              <a:t>mesurons</a:t>
+            </a:r>
+            <a:r>
+              <a:rPr lang="en-US" dirty="0"/>
+              <a:t> la </a:t>
+            </a:r>
+            <a:r>
+              <a:rPr lang="en-US" dirty="0" err="1"/>
+              <a:t>précision</a:t>
+            </a:r>
+            <a:r>
+              <a:rPr lang="en-US" dirty="0"/>
+              <a:t>, le rappel, le F1, le </a:t>
+            </a:r>
+            <a:r>
+              <a:rPr lang="en-US" dirty="0" err="1"/>
+              <a:t>niveau</a:t>
+            </a:r>
+            <a:r>
+              <a:rPr lang="en-US" dirty="0"/>
+              <a:t> de </a:t>
+            </a:r>
+            <a:r>
+              <a:rPr lang="en-US" dirty="0" err="1"/>
+              <a:t>gravité</a:t>
+            </a:r>
+            <a:r>
+              <a:rPr lang="en-US" dirty="0"/>
+              <a:t>, le </a:t>
+            </a:r>
+            <a:r>
+              <a:rPr lang="en-US" dirty="0" err="1"/>
+              <a:t>nombre</a:t>
+            </a:r>
+            <a:r>
+              <a:rPr lang="en-US" dirty="0"/>
+              <a:t> </a:t>
+            </a:r>
+            <a:r>
+              <a:rPr lang="en-US" dirty="0" err="1"/>
+              <a:t>d’alertes</a:t>
+            </a:r>
+            <a:r>
+              <a:rPr lang="en-US" dirty="0"/>
+              <a:t> par ordonnance et la </a:t>
+            </a:r>
+            <a:r>
+              <a:rPr lang="en-US" dirty="0" err="1"/>
+              <a:t>cohérence</a:t>
+            </a:r>
+            <a:r>
+              <a:rPr lang="en-US" dirty="0"/>
+              <a:t>.</a:t>
+            </a:r>
+            <a:br>
+              <a:rPr lang="en-US" dirty="0">
+                <a:cs typeface="+mn-lt"/>
+              </a:rPr>
+            </a:br>
+            <a:r>
+              <a:rPr lang="en-US" dirty="0"/>
+              <a:t>Comme chacun a </a:t>
+            </a:r>
+            <a:r>
+              <a:rPr lang="en-US" dirty="0" err="1"/>
+              <a:t>écrit</a:t>
+            </a:r>
+            <a:r>
+              <a:rPr lang="en-US" dirty="0"/>
+              <a:t> </a:t>
+            </a:r>
+            <a:r>
+              <a:rPr lang="en-US" dirty="0" err="1"/>
+              <a:t>ses</a:t>
+            </a:r>
+            <a:r>
+              <a:rPr lang="en-US" dirty="0"/>
+              <a:t> </a:t>
+            </a:r>
+            <a:r>
+              <a:rPr lang="en-US" dirty="0" err="1"/>
+              <a:t>règles</a:t>
+            </a:r>
+            <a:r>
+              <a:rPr lang="en-US" dirty="0"/>
+              <a:t> et </a:t>
+            </a:r>
+            <a:r>
+              <a:rPr lang="en-US" dirty="0" err="1"/>
+              <a:t>ses</a:t>
+            </a:r>
+            <a:r>
+              <a:rPr lang="en-US" dirty="0"/>
+              <a:t> ordonnances, nous </a:t>
+            </a:r>
+            <a:r>
+              <a:rPr lang="en-US" dirty="0" err="1"/>
+              <a:t>avons</a:t>
+            </a:r>
+            <a:r>
+              <a:rPr lang="en-US" dirty="0"/>
+              <a:t> </a:t>
+            </a:r>
+            <a:r>
+              <a:rPr lang="en-US" dirty="0" err="1"/>
+              <a:t>aussi</a:t>
+            </a:r>
+            <a:r>
+              <a:rPr lang="en-US" dirty="0"/>
+              <a:t> fait </a:t>
+            </a:r>
+            <a:r>
+              <a:rPr lang="en-US" dirty="0" err="1"/>
+              <a:t>une</a:t>
+            </a:r>
+            <a:r>
+              <a:rPr lang="en-US" dirty="0"/>
+              <a:t> </a:t>
+            </a:r>
+            <a:r>
+              <a:rPr lang="en-US" dirty="0" err="1"/>
+              <a:t>évaluation</a:t>
+            </a:r>
+            <a:r>
+              <a:rPr lang="en-US" dirty="0"/>
+              <a:t> </a:t>
+            </a:r>
+            <a:r>
+              <a:rPr lang="en-US" dirty="0" err="1"/>
+              <a:t>croisée</a:t>
+            </a:r>
+            <a:r>
+              <a:rPr lang="en-US" dirty="0"/>
+              <a:t> et </a:t>
+            </a:r>
+            <a:r>
+              <a:rPr lang="en-US" dirty="0" err="1"/>
+              <a:t>testé</a:t>
+            </a:r>
+            <a:r>
+              <a:rPr lang="en-US" dirty="0"/>
+              <a:t> 5 </a:t>
+            </a:r>
+            <a:r>
+              <a:rPr lang="en-US" dirty="0" err="1"/>
+              <a:t>cas</a:t>
+            </a:r>
+            <a:r>
+              <a:rPr lang="en-US" dirty="0"/>
+              <a:t> de </a:t>
+            </a:r>
+            <a:r>
+              <a:rPr lang="en-US" dirty="0" err="1"/>
+              <a:t>généralisation</a:t>
+            </a:r>
+            <a:r>
+              <a:rPr lang="en-US" dirty="0"/>
+              <a:t>.</a:t>
+            </a:r>
+            <a:br>
+              <a:rPr lang="en-US" dirty="0">
+                <a:cs typeface="+mn-lt"/>
+              </a:rPr>
+            </a:br>
+            <a:r>
+              <a:rPr lang="en-US" dirty="0" err="1"/>
+              <a:t>Enfin</a:t>
+            </a:r>
+            <a:r>
+              <a:rPr lang="en-US" dirty="0"/>
+              <a:t>, 16 </a:t>
+            </a:r>
+            <a:r>
+              <a:rPr lang="en-US" dirty="0" err="1"/>
+              <a:t>niveaux</a:t>
+            </a:r>
+            <a:r>
+              <a:rPr lang="en-US" dirty="0"/>
+              <a:t> de </a:t>
+            </a:r>
+            <a:r>
+              <a:rPr lang="en-US" dirty="0" err="1"/>
+              <a:t>gravité</a:t>
+            </a:r>
+            <a:r>
+              <a:rPr lang="en-US" dirty="0"/>
+              <a:t> </a:t>
+            </a:r>
+            <a:r>
+              <a:rPr lang="en-US" dirty="0" err="1"/>
+              <a:t>restent</a:t>
+            </a:r>
+            <a:r>
+              <a:rPr lang="en-US" dirty="0"/>
+              <a:t> à confirmer dans le </a:t>
+            </a:r>
+            <a:r>
+              <a:rPr lang="en-US" dirty="0" err="1"/>
+              <a:t>Thésaurus</a:t>
+            </a:r>
+            <a:r>
+              <a:rPr lang="en-US" dirty="0"/>
+              <a:t>.</a:t>
+            </a:r>
+            <a:br>
+              <a:rPr lang="en-US" dirty="0">
+                <a:cs typeface="+mn-lt"/>
+              </a:rPr>
+            </a:br>
+            <a:r>
+              <a:rPr lang="en-US" dirty="0"/>
+              <a:t>Je laisse </a:t>
+            </a:r>
+            <a:r>
+              <a:rPr lang="en-US" dirty="0" err="1"/>
+              <a:t>maintenant</a:t>
+            </a:r>
+            <a:r>
+              <a:rPr lang="en-US" dirty="0"/>
+              <a:t> la parole à Aziz pour les </a:t>
+            </a:r>
+            <a:r>
+              <a:rPr lang="en-US" dirty="0" err="1"/>
+              <a:t>résultats</a:t>
+            </a:r>
+            <a:r>
+              <a:rPr lang="en-US" dirty="0"/>
+              <a:t>.</a:t>
+            </a:r>
+            <a:endParaRPr lang="fr-FR" dirty="0"/>
+          </a:p>
+          <a:p>
+            <a:endParaRPr lang="en-US" dirty="0">
+              <a:ea typeface="Calibri"/>
+              <a:cs typeface="Calibri"/>
+            </a:endParaRPr>
           </a:p>
         </p:txBody>
       </p:sp>
@@ -8119,7 +11206,7 @@
         </p:nvGraphicFramePr>
         <p:xfrm>
           <a:off x="825500" y="2266950"/>
-          <a:ext cx="10553700" cy="2474714"/>
+          <a:ext cx="10553700" cy="2474715"/>
         </p:xfrm>
         <a:graphic>
           <a:graphicData uri="http://schemas.openxmlformats.org/drawingml/2006/table">

</xml_diff>